<commit_message>
refactor TCQL instructions and grammar handling; remove unused files and enhance monster creator with Handlebars templating
</commit_message>
<xml_diff>
--- a/StructuredOutputsPresentation.pptx
+++ b/StructuredOutputsPresentation.pptx
@@ -9,15 +9,15 @@
   </p:notesMasterIdLst>
   <p:sldIdLst>
     <p:sldId id="286" r:id="rId2"/>
-    <p:sldId id="287" r:id="rId3"/>
-    <p:sldId id="299" r:id="rId4"/>
-    <p:sldId id="289" r:id="rId5"/>
-    <p:sldId id="290" r:id="rId6"/>
-    <p:sldId id="300" r:id="rId7"/>
+    <p:sldId id="295" r:id="rId3"/>
+    <p:sldId id="287" r:id="rId4"/>
+    <p:sldId id="299" r:id="rId5"/>
+    <p:sldId id="289" r:id="rId6"/>
+    <p:sldId id="290" r:id="rId7"/>
     <p:sldId id="292" r:id="rId8"/>
-    <p:sldId id="293" r:id="rId9"/>
+    <p:sldId id="300" r:id="rId9"/>
     <p:sldId id="294" r:id="rId10"/>
-    <p:sldId id="295" r:id="rId11"/>
+    <p:sldId id="293" r:id="rId11"/>
     <p:sldId id="296" r:id="rId12"/>
     <p:sldId id="301" r:id="rId13"/>
     <p:sldId id="298" r:id="rId14"/>
@@ -595,7 +595,7 @@
           <a:p>
             <a:r>
               <a:rPr lang="en-US" dirty="0"/>
-              <a:t>DEMO: Real customer case study showing how switching from unstructured to structured responses improved their chatbot UX. Before: plain text blobs. After: rich UI components with cards, tables, and charts.</a:t>
+              <a:t>DEMO: Define tools with strict JSON Schema parameters and show how the model generates validated function arguments. No JSON.parse needed, no try-catch blocks. Show the Python SDK code.</a:t>
             </a:r>
           </a:p>
         </p:txBody>
@@ -825,7 +825,7 @@
       </p:grpSpPr>
       <p:sp>
         <p:nvSpPr>
-          <p:cNvPr id="2" name="Slide Image Placeholder 1"/>
+          <p:cNvPr id="2" name="Slide Image"/>
           <p:cNvSpPr>
             <a:spLocks noGrp="1" noRot="1" noChangeAspect="1"/>
           </p:cNvSpPr>
@@ -844,7 +844,7 @@
       </p:sp>
       <p:sp>
         <p:nvSpPr>
-          <p:cNvPr id="3" name="Notes Placeholder 2"/>
+          <p:cNvPr id="3" name="Notes"/>
           <p:cNvSpPr>
             <a:spLocks noGrp="1"/>
           </p:cNvSpPr>
@@ -859,7 +859,7 @@
           <a:p>
             <a:r>
               <a:rPr lang="en-US" dirty="0"/>
-              <a:t>Here's our roadmap for the next 60 minutes. We'll start with the concepts, explore the underlying technology, then jump into four live demos showing real-world applications.</a:t>
+              <a:t>DEMO: Real customer case study showing how switching from unstructured to structured responses improved their chatbot UX. Before: plain text blobs. After: rich UI components with cards, tables, and charts.</a:t>
             </a:r>
           </a:p>
         </p:txBody>
@@ -891,7 +891,7 @@
       </p:grpSpPr>
       <p:sp>
         <p:nvSpPr>
-          <p:cNvPr id="2" name="Slide Image"/>
+          <p:cNvPr id="2" name="Slide Image Placeholder 1"/>
           <p:cNvSpPr>
             <a:spLocks noGrp="1" noRot="1" noChangeAspect="1"/>
           </p:cNvSpPr>
@@ -910,7 +910,7 @@
       </p:sp>
       <p:sp>
         <p:nvSpPr>
-          <p:cNvPr id="3" name="Notes"/>
+          <p:cNvPr id="3" name="Notes Placeholder 2"/>
           <p:cNvSpPr>
             <a:spLocks noGrp="1"/>
           </p:cNvSpPr>
@@ -925,7 +925,7 @@
           <a:p>
             <a:r>
               <a:rPr lang="en-US" dirty="0"/>
-              <a:t>Structured Outputs constrain the LLM's response to match a predefined JSON Schema. Every response is guaranteed to be valid, parseable, and type-safe. No more regex parsing or retry loops.</a:t>
+              <a:t>Here's our roadmap for the next 60 minutes. We'll start with the concepts, explore the underlying technology, then jump into four live demos showing real-world applications.</a:t>
             </a:r>
           </a:p>
         </p:txBody>
@@ -991,7 +991,7 @@
           <a:p>
             <a:r>
               <a:rPr lang="en-US" dirty="0"/>
-              <a:t>The core problem: free-text LLM responses are inherently unpredictable. This causes crashes, parsing errors, and fragile glue code. Structured Outputs solve this at the model level.</a:t>
+              <a:t>Structured Outputs constrain the LLM's response to match a predefined JSON Schema. Every response is guaranteed to be valid, parseable, and type-safe. No more regex parsing or retry loops.</a:t>
             </a:r>
           </a:p>
         </p:txBody>
@@ -1057,7 +1057,7 @@
           <a:p>
             <a:r>
               <a:rPr lang="en-US" dirty="0"/>
-              <a:t>Full toolkit overview: JSON Mode for basic validity, Structured Outputs for full schema enforcement, Function Calling with validation, and Pydantic integration for Python developers. Available in Python, Node.js, and REST.</a:t>
+              <a:t>The core problem: free-text LLM responses are inherently unpredictable. This causes crashes, parsing errors, and fragile glue code. Structured Outputs solve this at the model level.</a:t>
             </a:r>
           </a:p>
         </p:txBody>
@@ -1123,7 +1123,7 @@
           <a:p>
             <a:r>
               <a:rPr lang="en-US" dirty="0"/>
-              <a:t>Under the hood, OpenAI converts your JSON Schema into a Context-Free Grammar. During token generation, the model can only sample tokens valid according to the grammar. Tools like Lark let you define custom grammars beyond JSON.</a:t>
+              <a:t>Full toolkit overview: JSON Mode for basic validity, Structured Outputs for full schema enforcement, Function Calling with validation, and Pydantic integration for Python developers. Available in Python, Node.js, and REST.</a:t>
             </a:r>
           </a:p>
         </p:txBody>
@@ -1255,7 +1255,7 @@
           <a:p>
             <a:r>
               <a:rPr lang="en-US" dirty="0"/>
-              <a:t>DEMO: Define tools with strict JSON Schema parameters and show how the model generates validated function arguments. No JSON.parse needed, no try-catch blocks. Show the Python SDK code.</a:t>
+              <a:t>Under the hood, OpenAI converts your JSON Schema into a Context-Free Grammar. During token generation, the model can only sample tokens valid according to the grammar. Tools like Lark let you define custom grammars beyond JSON.</a:t>
             </a:r>
           </a:p>
         </p:txBody>
@@ -4776,75 +4776,6 @@
       </p:sp>
       <p:sp>
         <p:nvSpPr>
-          <p:cNvPr id="51" name="DecoCircle"/>
-          <p:cNvSpPr/>
-          <p:nvPr/>
-        </p:nvSpPr>
-        <p:spPr>
-          <a:xfrm>
-            <a:off x="508000" y="508000"/>
-            <a:ext cx="762000" cy="762000"/>
-          </a:xfrm>
-          <a:prstGeom prst="ellipse">
-            <a:avLst/>
-          </a:prstGeom>
-          <a:noFill/>
-          <a:ln w="25400">
-            <a:solidFill>
-              <a:srgbClr val="00A3FF">
-                <a:alpha val="30000"/>
-              </a:srgbClr>
-            </a:solidFill>
-          </a:ln>
-        </p:spPr>
-        <p:txBody>
-          <a:bodyPr/>
-          <a:lstStyle/>
-          <a:p>
-            <a:endParaRPr lang="en-US"/>
-          </a:p>
-        </p:txBody>
-      </p:sp>
-      <p:sp>
-        <p:nvSpPr>
-          <p:cNvPr id="52" name="CodeBrace"/>
-          <p:cNvSpPr/>
-          <p:nvPr/>
-        </p:nvSpPr>
-        <p:spPr>
-          <a:xfrm>
-            <a:off x="635000" y="635000"/>
-            <a:ext cx="1016000" cy="1016000"/>
-          </a:xfrm>
-          <a:prstGeom prst="ellipse">
-            <a:avLst/>
-          </a:prstGeom>
-          <a:noFill/>
-          <a:ln>
-            <a:noFill/>
-          </a:ln>
-        </p:spPr>
-        <p:txBody>
-          <a:bodyPr wrap="none" anchor="ctr" anchorCtr="1"/>
-          <a:lstStyle/>
-          <a:p>
-            <a:pPr algn="ctr"/>
-            <a:r>
-              <a:rPr lang="en-US" sz="5400" dirty="0">
-                <a:solidFill>
-                  <a:srgbClr val="FFFFFF">
-                    <a:alpha val="15000"/>
-                  </a:srgbClr>
-                </a:solidFill>
-                <a:latin typeface="Consolas"/>
-              </a:rPr>
-              <a:t>{ }</a:t>
-            </a:r>
-          </a:p>
-        </p:txBody>
-      </p:sp>
-      <p:sp>
-        <p:nvSpPr>
           <p:cNvPr id="53" name="BottomInfo"/>
           <p:cNvSpPr/>
           <p:nvPr/>
@@ -4966,7 +4897,7 @@
           <p:cNvPr id="2" name="Title 1">
             <a:extLst>
               <a:ext uri="{FF2B5EF4-FFF2-40B4-BE49-F238E27FC236}">
-                <a16:creationId xmlns:a16="http://schemas.microsoft.com/office/drawing/2014/main" id="{D584E2DD-D5B6-41DA-9146-7F6C3B12DC0B}"/>
+                <a16:creationId xmlns:a16="http://schemas.microsoft.com/office/drawing/2014/main" id="{A805F6BA-EDA0-F569-CCEB-AE5E31C37AB5}"/>
               </a:ext>
             </a:extLst>
           </p:cNvPr>
@@ -4995,7 +4926,7 @@
                   <a:srgbClr val="FFFFFF"/>
                 </a:solidFill>
               </a:rPr>
-              <a:t>Demo: Customer UX Improvement</a:t>
+              <a:t>Demo: Function Calling &amp; Structured Outputs</a:t>
             </a:r>
           </a:p>
         </p:txBody>
@@ -5005,7 +4936,7 @@
           <p:cNvPr id="3" name="Text Placeholder 2">
             <a:extLst>
               <a:ext uri="{FF2B5EF4-FFF2-40B4-BE49-F238E27FC236}">
-                <a16:creationId xmlns:a16="http://schemas.microsoft.com/office/drawing/2014/main" id="{24AD6B3E-F152-1EFE-C88F-8D045166FE2C}"/>
+                <a16:creationId xmlns:a16="http://schemas.microsoft.com/office/drawing/2014/main" id="{42F815BD-8FAA-1824-4EF2-A1FA2281DC34}"/>
               </a:ext>
             </a:extLst>
           </p:cNvPr>
@@ -5034,7 +4965,7 @@
                   <a:srgbClr val="00A3FF"/>
                 </a:solidFill>
               </a:rPr>
-              <a:t>Real-world example of how Structured Outputs transformed a customer-facing application</a:t>
+              <a:t>Type-safe tool arguments with automatic schema validation in code</a:t>
             </a:r>
           </a:p>
         </p:txBody>
@@ -5123,7 +5054,7 @@
                 </a:solidFill>
                 <a:latin typeface="Segoe UI"/>
               </a:rPr>
-              <a:t>Before: unstructured chatbot responses with inconsistent UI rendering</a:t>
+              <a:t>Define function arguments with JSON Schema parameters</a:t>
             </a:r>
           </a:p>
           <a:p>
@@ -5133,9 +5064,9 @@
             </a:pPr>
             <a:endParaRPr lang="en-US" sz="2000" dirty="0">
               <a:solidFill>
-                <a:srgbClr val="FFFFFF"/>
+                <a:srgbClr val="FFC107"/>
               </a:solidFill>
-              <a:latin typeface="Segoe UI"/>
+              <a:latin typeface="Consolas"/>
             </a:endParaRPr>
           </a:p>
           <a:p>
@@ -5150,7 +5081,7 @@
                 </a:solidFill>
                 <a:latin typeface="Segoe UI"/>
               </a:rPr>
-              <a:t>After: structured response → UI components can be filled with structured data</a:t>
+              <a:t>Model generates validated function arguments - no parsing needed</a:t>
             </a:r>
           </a:p>
         </p:txBody>
@@ -5158,7 +5089,7 @@
     </p:spTree>
     <p:extLst>
       <p:ext uri="{BB962C8B-B14F-4D97-AF65-F5344CB8AC3E}">
-        <p14:creationId xmlns:p14="http://schemas.microsoft.com/office/powerpoint/2010/main" val="2311963777"/>
+        <p14:creationId xmlns:p14="http://schemas.microsoft.com/office/powerpoint/2010/main" val="2577444670"/>
       </p:ext>
     </p:extLst>
   </p:cSld>
@@ -5467,36 +5398,6 @@
           </a:p>
         </p:txBody>
       </p:sp>
-      <p:pic>
-        <p:nvPicPr>
-          <p:cNvPr id="4" name="Graphic 4" descr="Checklist icon for summary"/>
-          <p:cNvPicPr>
-            <a:picLocks noChangeAspect="1"/>
-          </p:cNvPicPr>
-          <p:nvPr/>
-        </p:nvPicPr>
-        <p:blipFill>
-          <a:blip r:embed="rId3">
-            <a:extLst>
-              <a:ext uri="{96DAC541-7B7A-43D3-8B79-37D633B846F1}">
-                <asvg:svgBlip xmlns:asvg="http://schemas.microsoft.com/office/drawing/2016/SVG/main" r:embed="rId4"/>
-              </a:ext>
-            </a:extLst>
-          </a:blip>
-          <a:stretch>
-            <a:fillRect/>
-          </a:stretch>
-        </p:blipFill>
-        <p:spPr>
-          <a:xfrm>
-            <a:off x="11176000" y="444500"/>
-            <a:ext cx="609600" cy="609600"/>
-          </a:xfrm>
-          <a:prstGeom prst="rect">
-            <a:avLst/>
-          </a:prstGeom>
-        </p:spPr>
-      </p:pic>
     </p:spTree>
     <p:extLst>
       <p:ext uri="{BB962C8B-B14F-4D97-AF65-F5344CB8AC3E}">
@@ -5809,6 +5710,16 @@
 <file path=ppt/slides/slide2.xml><?xml version="1.0" encoding="utf-8"?>
 <p:sld xmlns:a="http://schemas.openxmlformats.org/drawingml/2006/main" xmlns:r="http://schemas.openxmlformats.org/officeDocument/2006/relationships" xmlns:p="http://schemas.openxmlformats.org/presentationml/2006/main">
   <p:cSld>
+    <p:bg>
+      <p:bgPr>
+        <a:solidFill>
+          <a:srgbClr val="001A4D">
+            <a:alpha val="100000"/>
+          </a:srgbClr>
+        </a:solidFill>
+        <a:effectLst/>
+      </p:bgPr>
+    </p:bg>
     <p:spTree>
       <p:nvGrpSpPr>
         <p:cNvPr id="1" name=""/>
@@ -5828,7 +5739,7 @@
           <p:cNvPr id="2" name="Title 1">
             <a:extLst>
               <a:ext uri="{FF2B5EF4-FFF2-40B4-BE49-F238E27FC236}">
-                <a16:creationId xmlns:a16="http://schemas.microsoft.com/office/drawing/2014/main" id="{1D436B5D-3BE6-AADE-963F-ED180D6031EA}"/>
+                <a16:creationId xmlns:a16="http://schemas.microsoft.com/office/drawing/2014/main" id="{D584E2DD-D5B6-41DA-9146-7F6C3B12DC0B}"/>
               </a:ext>
             </a:extLst>
           </p:cNvPr>
@@ -5839,7 +5750,12 @@
             <p:ph type="title"/>
           </p:nvPr>
         </p:nvSpPr>
-        <p:spPr/>
+        <p:spPr>
+          <a:xfrm>
+            <a:off x="831850" y="1016000"/>
+            <a:ext cx="10515600" cy="1524000"/>
+          </a:xfrm>
+        </p:spPr>
         <p:txBody>
           <a:bodyPr>
             <a:normAutofit/>
@@ -5847,36 +5763,36 @@
           <a:lstStyle/>
           <a:p>
             <a:r>
-              <a:rPr lang="en-US" sz="3200" b="1" dirty="0">
-                <a:solidFill>
-                  <a:srgbClr val="0052CC"/>
-                </a:solidFill>
-              </a:rPr>
-              <a:t>Agenda</a:t>
-            </a:r>
-          </a:p>
-        </p:txBody>
-      </p:sp>
-      <p:sp>
-        <p:nvSpPr>
-          <p:cNvPr id="3" name="Content Placeholder 2">
-            <a:extLst>
-              <a:ext uri="{FF2B5EF4-FFF2-40B4-BE49-F238E27FC236}">
-                <a16:creationId xmlns:a16="http://schemas.microsoft.com/office/drawing/2014/main" id="{FDFE5B8B-2B52-68A5-9EC9-F1D8CF69B902}"/>
-              </a:ext>
-            </a:extLst>
-          </p:cNvPr>
-          <p:cNvSpPr>
-            <a:spLocks noGrp="1"/>
-          </p:cNvSpPr>
-          <p:nvPr>
-            <p:ph idx="1"/>
+              <a:rPr lang="en-US" sz="2800" b="1">
+                <a:solidFill>
+                  <a:srgbClr val="FFFFFF"/>
+                </a:solidFill>
+              </a:rPr>
+              <a:t>Demo: Customer UX Improvement</a:t>
+            </a:r>
+          </a:p>
+        </p:txBody>
+      </p:sp>
+      <p:sp>
+        <p:nvSpPr>
+          <p:cNvPr id="3" name="Text Placeholder 2">
+            <a:extLst>
+              <a:ext uri="{FF2B5EF4-FFF2-40B4-BE49-F238E27FC236}">
+                <a16:creationId xmlns:a16="http://schemas.microsoft.com/office/drawing/2014/main" id="{24AD6B3E-F152-1EFE-C88F-8D045166FE2C}"/>
+              </a:ext>
+            </a:extLst>
+          </p:cNvPr>
+          <p:cNvSpPr>
+            <a:spLocks noGrp="1"/>
+          </p:cNvSpPr>
+          <p:nvPr>
+            <p:ph type="body" idx="1"/>
           </p:nvPr>
         </p:nvSpPr>
         <p:spPr>
           <a:xfrm>
-            <a:off x="838200" y="1905000"/>
-            <a:ext cx="10515600" cy="4191000"/>
+            <a:off x="831850" y="2540000"/>
+            <a:ext cx="10515600" cy="762000"/>
           </a:xfrm>
         </p:spPr>
         <p:txBody>
@@ -5885,159 +5801,129 @@
           </a:bodyPr>
           <a:lstStyle/>
           <a:p>
+            <a:r>
+              <a:rPr lang="en-US" sz="1800">
+                <a:solidFill>
+                  <a:srgbClr val="00A3FF"/>
+                </a:solidFill>
+              </a:rPr>
+              <a:t>Real-world example of how Structured Outputs transformed a customer-facing application</a:t>
+            </a:r>
+          </a:p>
+        </p:txBody>
+      </p:sp>
+      <p:sp>
+        <p:nvSpPr>
+          <p:cNvPr id="60" name="DemoBadge"/>
+          <p:cNvSpPr/>
+          <p:nvPr/>
+        </p:nvSpPr>
+        <p:spPr>
+          <a:xfrm>
+            <a:off x="457200" y="254000"/>
+            <a:ext cx="2286000" cy="457200"/>
+          </a:xfrm>
+          <a:prstGeom prst="roundRect">
+            <a:avLst>
+              <a:gd name="adj" fmla="val 16667"/>
+            </a:avLst>
+          </a:prstGeom>
+          <a:solidFill>
+            <a:srgbClr val="FFC107"/>
+          </a:solidFill>
+          <a:ln>
+            <a:noFill/>
+          </a:ln>
+        </p:spPr>
+        <p:txBody>
+          <a:bodyPr anchor="ctr" anchorCtr="1"/>
+          <a:lstStyle/>
+          <a:p>
+            <a:pPr algn="ctr"/>
+            <a:r>
+              <a:rPr lang="en-US" sz="1800" b="1" dirty="0">
+                <a:solidFill>
+                  <a:srgbClr val="001A4D"/>
+                </a:solidFill>
+                <a:latin typeface="Segoe UI Semibold"/>
+              </a:rPr>
+              <a:t>▶  LIVE DEMO</a:t>
+            </a:r>
+          </a:p>
+        </p:txBody>
+      </p:sp>
+      <p:sp>
+        <p:nvSpPr>
+          <p:cNvPr id="61" name="KeyPoints"/>
+          <p:cNvSpPr/>
+          <p:nvPr/>
+        </p:nvSpPr>
+        <p:spPr>
+          <a:xfrm>
+            <a:off x="457200" y="3556000"/>
+            <a:ext cx="11277600" cy="1270000"/>
+          </a:xfrm>
+          <a:prstGeom prst="roundRect">
+            <a:avLst>
+              <a:gd name="adj" fmla="val 8333"/>
+            </a:avLst>
+          </a:prstGeom>
+          <a:solidFill>
+            <a:srgbClr val="FFFFFF">
+              <a:alpha val="10000"/>
+            </a:srgbClr>
+          </a:solidFill>
+          <a:ln w="12700">
+            <a:solidFill>
+              <a:srgbClr val="00A3FF">
+                <a:alpha val="40000"/>
+              </a:srgbClr>
+            </a:solidFill>
+          </a:ln>
+        </p:spPr>
+        <p:txBody>
+          <a:bodyPr lIns="182880" tIns="91440" rIns="182880" bIns="91440" anchor="t"/>
+          <a:lstStyle/>
+          <a:p>
             <a:pPr>
-              <a:buFont typeface="Segoe UI Semibold"/>
-              <a:buAutoNum type="arabicPeriod"/>
+              <a:buFont typeface="Arial"/>
+              <a:buChar char="▸"/>
             </a:pPr>
             <a:r>
-              <a:rPr lang="en-US" sz="2400" dirty="0">
-                <a:solidFill>
-                  <a:srgbClr val="2E2E2E"/>
+              <a:rPr lang="en-US" sz="2000" dirty="0">
+                <a:solidFill>
+                  <a:srgbClr val="FFFFFF"/>
                 </a:solidFill>
                 <a:latin typeface="Segoe UI"/>
               </a:rPr>
-              <a:t> What is Structured Output?</a:t>
+              <a:t>Before: unstructured chatbot responses with inconsistent UI rendering</a:t>
             </a:r>
           </a:p>
           <a:p>
             <a:pPr>
-              <a:buFont typeface="Segoe UI Semibold"/>
-              <a:buAutoNum type="arabicPeriod"/>
+              <a:buFont typeface="Arial"/>
+              <a:buChar char="▸"/>
             </a:pPr>
-            <a:r>
-              <a:rPr lang="en-US" sz="2400" dirty="0">
-                <a:solidFill>
-                  <a:srgbClr val="2E2E2E"/>
+            <a:endParaRPr lang="en-US" sz="2000" dirty="0">
+              <a:solidFill>
+                <a:srgbClr val="FFFFFF"/>
+              </a:solidFill>
+              <a:latin typeface="Segoe UI"/>
+            </a:endParaRPr>
+          </a:p>
+          <a:p>
+            <a:pPr>
+              <a:buFont typeface="Arial"/>
+              <a:buChar char="▸"/>
+            </a:pPr>
+            <a:r>
+              <a:rPr lang="en-US" sz="2000" dirty="0">
+                <a:solidFill>
+                  <a:srgbClr val="FFFFFF"/>
                 </a:solidFill>
                 <a:latin typeface="Segoe UI"/>
               </a:rPr>
-              <a:t> Motivation: Why Structured Output?</a:t>
-            </a:r>
-          </a:p>
-          <a:p>
-            <a:pPr>
-              <a:buFont typeface="Segoe UI Semibold"/>
-              <a:buAutoNum type="arabicPeriod"/>
-            </a:pPr>
-            <a:r>
-              <a:rPr lang="en-US" sz="2400" dirty="0">
-                <a:solidFill>
-                  <a:srgbClr val="2E2E2E"/>
-                </a:solidFill>
-                <a:latin typeface="Segoe UI"/>
-              </a:rPr>
-              <a:t> Usages Overview</a:t>
-            </a:r>
-          </a:p>
-          <a:p>
-            <a:pPr>
-              <a:buFont typeface="Segoe UI Semibold"/>
-              <a:buAutoNum type="arabicPeriod"/>
-            </a:pPr>
-            <a:r>
-              <a:rPr lang="en-US" sz="2400" dirty="0">
-                <a:solidFill>
-                  <a:srgbClr val="2E2E2E"/>
-                </a:solidFill>
-                <a:latin typeface="Segoe UI"/>
-              </a:rPr>
-              <a:t> Context-Free Grammar (CFG)</a:t>
-            </a:r>
-          </a:p>
-          <a:p>
-            <a:pPr>
-              <a:buFont typeface="Segoe UI Semibold"/>
-              <a:buAutoNum type="arabicPeriod"/>
-            </a:pPr>
-            <a:r>
-              <a:rPr lang="en-US" sz="2400" dirty="0">
-                <a:latin typeface="Segoe UI"/>
-              </a:rPr>
-              <a:t> </a:t>
-            </a:r>
-            <a:r>
-              <a:rPr lang="en-US" sz="2400" dirty="0">
-                <a:solidFill>
-                  <a:srgbClr val="0052CC"/>
-                </a:solidFill>
-                <a:ea typeface="+mj-ea"/>
-                <a:cs typeface="+mj-cs"/>
-                <a:hlinkClick r:id="rId3">
-                  <a:extLst>
-                    <a:ext uri="{A12FA001-AC4F-418D-AE19-62706E023703}">
-                      <ahyp:hlinkClr xmlns:ahyp="http://schemas.microsoft.com/office/drawing/2018/hyperlinkcolor" val="tx"/>
-                    </a:ext>
-                  </a:extLst>
-                </a:hlinkClick>
-              </a:rPr>
-              <a:t>Demos:</a:t>
-            </a:r>
-            <a:r>
-              <a:rPr lang="en-US" sz="2400" dirty="0">
-                <a:solidFill>
-                  <a:srgbClr val="0052CC"/>
-                </a:solidFill>
-                <a:ea typeface="+mj-ea"/>
-                <a:cs typeface="+mj-cs"/>
-              </a:rPr>
-              <a:t> </a:t>
-            </a:r>
-            <a:r>
-              <a:rPr lang="en-US" sz="2400" dirty="0">
-                <a:solidFill>
-                  <a:srgbClr val="2E2E2E"/>
-                </a:solidFill>
-                <a:latin typeface="Segoe UI"/>
-              </a:rPr>
-              <a:t>Contract Extraction, Function Calling, Lark CFG, Real-World UX</a:t>
-            </a:r>
-          </a:p>
-          <a:p>
-            <a:pPr>
-              <a:buFont typeface="Segoe UI Semibold"/>
-              <a:buAutoNum type="arabicPeriod"/>
-            </a:pPr>
-            <a:r>
-              <a:rPr lang="en-US" sz="2400" dirty="0">
-                <a:solidFill>
-                  <a:srgbClr val="2E2E2E"/>
-                </a:solidFill>
-                <a:latin typeface="Segoe UI"/>
-              </a:rPr>
-              <a:t> Summary</a:t>
-            </a:r>
-            <a:r>
-              <a:rPr lang="en-US" sz="2400" dirty="0">
-                <a:solidFill>
-                  <a:schemeClr val="tx1"/>
-                </a:solidFill>
-                <a:latin typeface="Segoe UI"/>
-              </a:rPr>
-              <a:t> &amp; </a:t>
-            </a:r>
-            <a:r>
-              <a:rPr lang="en-US" sz="2400" dirty="0">
-                <a:solidFill>
-                  <a:srgbClr val="2E2E2E"/>
-                </a:solidFill>
-                <a:latin typeface="Segoe UI"/>
-              </a:rPr>
-              <a:t>Takeaways</a:t>
-            </a:r>
-          </a:p>
-          <a:p>
-            <a:pPr>
-              <a:buFont typeface="Segoe UI Semibold"/>
-              <a:buAutoNum type="arabicPeriod"/>
-            </a:pPr>
-            <a:r>
-              <a:rPr lang="en-US" sz="2400" dirty="0">
-                <a:solidFill>
-                  <a:srgbClr val="2E2E2E"/>
-                </a:solidFill>
-                <a:latin typeface="Segoe UI"/>
-              </a:rPr>
-              <a:t> Q&amp;A</a:t>
+              <a:t>After: structured response → UI components can be filled with structured data</a:t>
             </a:r>
           </a:p>
         </p:txBody>
@@ -6045,7 +5931,7 @@
     </p:spTree>
     <p:extLst>
       <p:ext uri="{BB962C8B-B14F-4D97-AF65-F5344CB8AC3E}">
-        <p14:creationId xmlns:p14="http://schemas.microsoft.com/office/powerpoint/2010/main" val="1075574473"/>
+        <p14:creationId xmlns:p14="http://schemas.microsoft.com/office/powerpoint/2010/main" val="2311963777"/>
       </p:ext>
     </p:extLst>
   </p:cSld>
@@ -6077,7 +5963,7 @@
           <p:cNvPr id="2" name="Title 1">
             <a:extLst>
               <a:ext uri="{FF2B5EF4-FFF2-40B4-BE49-F238E27FC236}">
-                <a16:creationId xmlns:a16="http://schemas.microsoft.com/office/drawing/2014/main" id="{D5F70657-8670-1F48-0E1D-E014DD80B467}"/>
+                <a16:creationId xmlns:a16="http://schemas.microsoft.com/office/drawing/2014/main" id="{1D436B5D-3BE6-AADE-963F-ED180D6031EA}"/>
               </a:ext>
             </a:extLst>
           </p:cNvPr>
@@ -6096,12 +5982,12 @@
           <a:lstStyle/>
           <a:p>
             <a:r>
-              <a:rPr lang="en-US" sz="3200" b="1">
+              <a:rPr lang="en-US" sz="3200" b="1" dirty="0">
                 <a:solidFill>
                   <a:srgbClr val="0052CC"/>
                 </a:solidFill>
               </a:rPr>
-              <a:t>What is Structured Output?</a:t>
+              <a:t>Agenda</a:t>
             </a:r>
           </a:p>
         </p:txBody>
@@ -6111,7 +5997,7 @@
           <p:cNvPr id="3" name="Content Placeholder 2">
             <a:extLst>
               <a:ext uri="{FF2B5EF4-FFF2-40B4-BE49-F238E27FC236}">
-                <a16:creationId xmlns:a16="http://schemas.microsoft.com/office/drawing/2014/main" id="{8FF70A8E-8EC8-5836-4570-D63A701090BB}"/>
+                <a16:creationId xmlns:a16="http://schemas.microsoft.com/office/drawing/2014/main" id="{FDFE5B8B-2B52-68A5-9EC9-F1D8CF69B902}"/>
               </a:ext>
             </a:extLst>
           </p:cNvPr>
@@ -6124,8 +6010,8 @@
         </p:nvSpPr>
         <p:spPr>
           <a:xfrm>
-            <a:off x="838200" y="1484671"/>
-            <a:ext cx="10515600" cy="4611329"/>
+            <a:off x="838200" y="1905000"/>
+            <a:ext cx="10515600" cy="4191000"/>
           </a:xfrm>
         </p:spPr>
         <p:txBody>
@@ -6135,242 +6021,166 @@
           <a:lstStyle/>
           <a:p>
             <a:pPr>
-              <a:buNone/>
+              <a:buFont typeface="Segoe UI Semibold"/>
+              <a:buAutoNum type="arabicPeriod"/>
             </a:pPr>
             <a:r>
-              <a:rPr lang="en-US" sz="2000" b="1" dirty="0">
+              <a:rPr lang="en-US" sz="2400" dirty="0">
+                <a:solidFill>
+                  <a:srgbClr val="2E2E2E"/>
+                </a:solidFill>
+                <a:latin typeface="Segoe UI"/>
+              </a:rPr>
+              <a:t> What is Structured Output?</a:t>
+            </a:r>
+          </a:p>
+          <a:p>
+            <a:pPr>
+              <a:buFont typeface="Segoe UI Semibold"/>
+              <a:buAutoNum type="arabicPeriod"/>
+            </a:pPr>
+            <a:r>
+              <a:rPr lang="en-US" sz="2400" dirty="0">
+                <a:solidFill>
+                  <a:srgbClr val="2E2E2E"/>
+                </a:solidFill>
+                <a:latin typeface="Segoe UI"/>
+              </a:rPr>
+              <a:t> Motivation: Why Structured Output?</a:t>
+            </a:r>
+          </a:p>
+          <a:p>
+            <a:pPr>
+              <a:buFont typeface="Segoe UI Semibold"/>
+              <a:buAutoNum type="arabicPeriod"/>
+            </a:pPr>
+            <a:r>
+              <a:rPr lang="en-US" sz="2400" dirty="0">
+                <a:solidFill>
+                  <a:srgbClr val="2E2E2E"/>
+                </a:solidFill>
+                <a:latin typeface="Segoe UI"/>
+              </a:rPr>
+              <a:t> Usages Overview</a:t>
+            </a:r>
+          </a:p>
+          <a:p>
+            <a:pPr>
+              <a:buFont typeface="Segoe UI Semibold"/>
+              <a:buAutoNum type="arabicPeriod"/>
+            </a:pPr>
+            <a:r>
+              <a:rPr lang="en-US" sz="2400" dirty="0">
+                <a:solidFill>
+                  <a:srgbClr val="2E2E2E"/>
+                </a:solidFill>
+                <a:latin typeface="Segoe UI"/>
+              </a:rPr>
+              <a:t> Context-Free Grammar (CFG)</a:t>
+            </a:r>
+          </a:p>
+          <a:p>
+            <a:pPr>
+              <a:buFont typeface="Segoe UI Semibold"/>
+              <a:buAutoNum type="arabicPeriod"/>
+            </a:pPr>
+            <a:r>
+              <a:rPr lang="en-US" sz="2400" dirty="0">
+                <a:latin typeface="Segoe UI"/>
+              </a:rPr>
+              <a:t> </a:t>
+            </a:r>
+            <a:r>
+              <a:rPr lang="en-US" sz="2400" dirty="0">
                 <a:solidFill>
                   <a:srgbClr val="0052CC"/>
                 </a:solidFill>
-                <a:latin typeface="Segoe UI Semibold"/>
-              </a:rPr>
-              <a:t>Definition</a:t>
+                <a:ea typeface="+mj-ea"/>
+                <a:cs typeface="+mj-cs"/>
+                <a:hlinkClick r:id="rId3">
+                  <a:extLst>
+                    <a:ext uri="{A12FA001-AC4F-418D-AE19-62706E023703}">
+                      <ahyp:hlinkClr xmlns:ahyp="http://schemas.microsoft.com/office/drawing/2018/hyperlinkcolor" val="tx"/>
+                    </a:ext>
+                  </a:extLst>
+                </a:hlinkClick>
+              </a:rPr>
+              <a:t>Demos:</a:t>
+            </a:r>
+            <a:r>
+              <a:rPr lang="en-US" sz="2400" dirty="0">
+                <a:solidFill>
+                  <a:srgbClr val="0052CC"/>
+                </a:solidFill>
+                <a:ea typeface="+mj-ea"/>
+                <a:cs typeface="+mj-cs"/>
+              </a:rPr>
+              <a:t> </a:t>
+            </a:r>
+            <a:r>
+              <a:rPr lang="en-US" sz="2400" dirty="0">
+                <a:solidFill>
+                  <a:srgbClr val="2E2E2E"/>
+                </a:solidFill>
+                <a:latin typeface="Segoe UI"/>
+              </a:rPr>
+              <a:t>Contract Extraction, Function Calling, Lark CFG, Real-World UX</a:t>
             </a:r>
           </a:p>
           <a:p>
             <a:pPr>
-              <a:buFont typeface="Arial"/>
-              <a:buChar char="▸"/>
+              <a:buFont typeface="Segoe UI Semibold"/>
+              <a:buAutoNum type="arabicPeriod"/>
             </a:pPr>
             <a:r>
-              <a:rPr lang="en-US" sz="2000" dirty="0">
+              <a:rPr lang="en-US" sz="2400" dirty="0">
                 <a:solidFill>
                   <a:srgbClr val="2E2E2E"/>
                 </a:solidFill>
                 <a:latin typeface="Segoe UI"/>
               </a:rPr>
-              <a:t>LLM responses constrained to a </a:t>
-            </a:r>
-            <a:r>
-              <a:rPr lang="en-US" sz="2000" b="1" dirty="0">
-                <a:solidFill>
-                  <a:srgbClr val="0052CC"/>
+              <a:t> Summary</a:t>
+            </a:r>
+            <a:r>
+              <a:rPr lang="en-US" sz="2400" dirty="0">
+                <a:solidFill>
+                  <a:schemeClr val="tx1"/>
                 </a:solidFill>
                 <a:latin typeface="Segoe UI"/>
               </a:rPr>
-              <a:t>predefined JSON Schema</a:t>
+              <a:t> &amp; </a:t>
+            </a:r>
+            <a:r>
+              <a:rPr lang="en-US" sz="2400" dirty="0">
+                <a:solidFill>
+                  <a:srgbClr val="2E2E2E"/>
+                </a:solidFill>
+                <a:latin typeface="Segoe UI"/>
+              </a:rPr>
+              <a:t>Takeaways</a:t>
             </a:r>
           </a:p>
           <a:p>
             <a:pPr>
-              <a:buFont typeface="Arial"/>
-              <a:buChar char="▸"/>
+              <a:buFont typeface="Segoe UI Semibold"/>
+              <a:buAutoNum type="arabicPeriod"/>
             </a:pPr>
             <a:r>
-              <a:rPr lang="en-US" sz="2000" dirty="0">
+              <a:rPr lang="en-US" sz="2400" dirty="0">
                 <a:solidFill>
                   <a:srgbClr val="2E2E2E"/>
                 </a:solidFill>
                 <a:latin typeface="Segoe UI"/>
               </a:rPr>
-              <a:t>Guarantees </a:t>
-            </a:r>
-            <a:r>
-              <a:rPr lang="en-US" sz="2000" b="1" dirty="0">
-                <a:solidFill>
-                  <a:srgbClr val="0052CC"/>
-                </a:solidFill>
-                <a:latin typeface="Segoe UI"/>
-              </a:rPr>
-              <a:t>type-safe, parseable output</a:t>
-            </a:r>
-            <a:r>
-              <a:rPr lang="en-US" sz="2000" dirty="0">
-                <a:solidFill>
-                  <a:srgbClr val="2E2E2E"/>
-                </a:solidFill>
-                <a:latin typeface="Segoe UI"/>
-              </a:rPr>
-              <a:t> every time</a:t>
-            </a:r>
-          </a:p>
-          <a:p>
-            <a:pPr>
-              <a:buFont typeface="Arial"/>
-              <a:buChar char="▸"/>
-            </a:pPr>
-            <a:r>
-              <a:rPr lang="en-US" sz="2000" dirty="0">
-                <a:solidFill>
-                  <a:srgbClr val="2E2E2E"/>
-                </a:solidFill>
-                <a:latin typeface="Segoe UI"/>
-              </a:rPr>
-              <a:t>Eliminates post-processing, regex, and retry logic</a:t>
-            </a:r>
-          </a:p>
-          <a:p>
-            <a:pPr>
-              <a:buFont typeface="Arial"/>
-              <a:buChar char="▸"/>
-            </a:pPr>
-            <a:endParaRPr lang="en-US" sz="2000" dirty="0">
-              <a:latin typeface="Segoe UI"/>
-            </a:endParaRPr>
-          </a:p>
-          <a:p>
-            <a:pPr marL="0" indent="0">
-              <a:buNone/>
-            </a:pPr>
-            <a:r>
-              <a:rPr lang="en-US" sz="2000" b="1" dirty="0">
-                <a:solidFill>
-                  <a:srgbClr val="0052CC"/>
-                </a:solidFill>
-                <a:latin typeface="Segoe UI Semibold"/>
-              </a:rPr>
-              <a:t>In this talk we focus on OpenAI</a:t>
-            </a:r>
-          </a:p>
-          <a:p>
-            <a:pPr>
-              <a:buFont typeface="Arial"/>
-              <a:buChar char="▸"/>
-            </a:pPr>
-            <a:r>
-              <a:rPr lang="en-US" sz="2000" dirty="0"/>
-              <a:t>other providers offer similar functionality (e.g. </a:t>
-            </a:r>
-            <a:r>
-              <a:rPr lang="en-US" sz="2000" dirty="0">
-                <a:hlinkClick r:id="rId3"/>
-              </a:rPr>
-              <a:t>Anthropic</a:t>
-            </a:r>
-            <a:r>
-              <a:rPr lang="en-US" sz="2000" dirty="0"/>
-              <a:t>)</a:t>
-            </a:r>
-          </a:p>
-          <a:p>
-            <a:pPr>
-              <a:buFont typeface="Arial"/>
-              <a:buChar char="▸"/>
-            </a:pPr>
-            <a:endParaRPr lang="en-US" sz="2000" dirty="0"/>
-          </a:p>
-          <a:p>
-            <a:pPr marL="0" indent="0">
-              <a:buNone/>
-            </a:pPr>
-            <a:r>
-              <a:rPr lang="en-US" sz="2000" b="1" dirty="0">
-                <a:solidFill>
-                  <a:srgbClr val="0052CC"/>
-                </a:solidFill>
-                <a:latin typeface="Segoe UI Semibold"/>
-              </a:rPr>
-              <a:t>If you need </a:t>
-            </a:r>
-            <a:r>
-              <a:rPr lang="en-US" sz="2000" b="1" dirty="0" err="1">
-                <a:solidFill>
-                  <a:srgbClr val="0052CC"/>
-                </a:solidFill>
-                <a:latin typeface="Segoe UI Semibold"/>
-              </a:rPr>
-              <a:t>Xplat</a:t>
-            </a:r>
-            <a:r>
-              <a:rPr lang="en-US" sz="2000" b="1" dirty="0">
-                <a:solidFill>
-                  <a:srgbClr val="0052CC"/>
-                </a:solidFill>
-                <a:latin typeface="Segoe UI Semibold"/>
-              </a:rPr>
-              <a:t>, consider …</a:t>
-            </a:r>
-          </a:p>
-          <a:p>
-            <a:pPr>
-              <a:buFont typeface="Arial"/>
-              <a:buChar char="▸"/>
-            </a:pPr>
-            <a:r>
-              <a:rPr lang="en-US" sz="2000" dirty="0"/>
-              <a:t>… libs like </a:t>
-            </a:r>
-            <a:r>
-              <a:rPr lang="en-US" sz="2000" dirty="0">
-                <a:hlinkClick r:id="rId4"/>
-              </a:rPr>
-              <a:t>Instructor</a:t>
-            </a:r>
-            <a:endParaRPr lang="en-US" sz="2000" dirty="0"/>
-          </a:p>
-          <a:p>
-            <a:pPr>
-              <a:buFont typeface="Arial"/>
-              <a:buChar char="▸"/>
-            </a:pPr>
-            <a:r>
-              <a:rPr lang="en-US" sz="2000" dirty="0"/>
-              <a:t>… proxies like </a:t>
-            </a:r>
-            <a:r>
-              <a:rPr lang="en-US" sz="2000" dirty="0">
-                <a:hlinkClick r:id="rId5"/>
-              </a:rPr>
-              <a:t>LiteLLM</a:t>
-            </a:r>
-            <a:endParaRPr lang="en-US" sz="2000" dirty="0"/>
-          </a:p>
-        </p:txBody>
-      </p:sp>
-      <p:pic>
-        <p:nvPicPr>
-          <p:cNvPr id="4" name="Graphic 4" descr="Lightbulb icon for definition"/>
-          <p:cNvPicPr>
-            <a:picLocks noChangeAspect="1"/>
-          </p:cNvPicPr>
-          <p:nvPr/>
-        </p:nvPicPr>
-        <p:blipFill>
-          <a:blip r:embed="rId6">
-            <a:extLst>
-              <a:ext uri="{96DAC541-7B7A-43D3-8B79-37D633B846F1}">
-                <asvg:svgBlip xmlns:asvg="http://schemas.microsoft.com/office/drawing/2016/SVG/main" r:embed="rId7"/>
-              </a:ext>
-            </a:extLst>
-          </a:blip>
-          <a:stretch>
-            <a:fillRect/>
-          </a:stretch>
-        </p:blipFill>
-        <p:spPr>
-          <a:xfrm>
-            <a:off x="11176000" y="444500"/>
-            <a:ext cx="609600" cy="609600"/>
-          </a:xfrm>
-          <a:prstGeom prst="rect">
-            <a:avLst/>
-          </a:prstGeom>
-        </p:spPr>
-      </p:pic>
+              <a:t> Q&amp;A</a:t>
+            </a:r>
+          </a:p>
+        </p:txBody>
+      </p:sp>
     </p:spTree>
     <p:extLst>
       <p:ext uri="{BB962C8B-B14F-4D97-AF65-F5344CB8AC3E}">
-        <p14:creationId xmlns:p14="http://schemas.microsoft.com/office/powerpoint/2010/main" val="405869426"/>
+        <p14:creationId xmlns:p14="http://schemas.microsoft.com/office/powerpoint/2010/main" val="1075574473"/>
       </p:ext>
     </p:extLst>
   </p:cSld>
@@ -6402,7 +6212,7 @@
           <p:cNvPr id="2" name="Title 1">
             <a:extLst>
               <a:ext uri="{FF2B5EF4-FFF2-40B4-BE49-F238E27FC236}">
-                <a16:creationId xmlns:a16="http://schemas.microsoft.com/office/drawing/2014/main" id="{7A5C2B88-C751-7A6A-1C3D-B481F9C9E4F9}"/>
+                <a16:creationId xmlns:a16="http://schemas.microsoft.com/office/drawing/2014/main" id="{D5F70657-8670-1F48-0E1D-E014DD80B467}"/>
               </a:ext>
             </a:extLst>
           </p:cNvPr>
@@ -6426,7 +6236,7 @@
                   <a:srgbClr val="0052CC"/>
                 </a:solidFill>
               </a:rPr>
-              <a:t>Motivation: Why Structured Output?</a:t>
+              <a:t>What is Structured Output?</a:t>
             </a:r>
           </a:p>
         </p:txBody>
@@ -6436,7 +6246,7 @@
           <p:cNvPr id="3" name="Content Placeholder 2">
             <a:extLst>
               <a:ext uri="{FF2B5EF4-FFF2-40B4-BE49-F238E27FC236}">
-                <a16:creationId xmlns:a16="http://schemas.microsoft.com/office/drawing/2014/main" id="{61C51AB3-776D-839E-45DF-B3A756BBEA6D}"/>
+                <a16:creationId xmlns:a16="http://schemas.microsoft.com/office/drawing/2014/main" id="{8FF70A8E-8EC8-5836-4570-D63A701090BB}"/>
               </a:ext>
             </a:extLst>
           </p:cNvPr>
@@ -6449,8 +6259,8 @@
         </p:nvSpPr>
         <p:spPr>
           <a:xfrm>
-            <a:off x="838200" y="1905000"/>
-            <a:ext cx="10515600" cy="4191000"/>
+            <a:off x="838200" y="1484671"/>
+            <a:ext cx="10515600" cy="4611329"/>
           </a:xfrm>
         </p:spPr>
         <p:txBody>
@@ -6465,11 +6275,11 @@
             <a:r>
               <a:rPr lang="en-US" sz="2000" b="1" dirty="0">
                 <a:solidFill>
-                  <a:srgbClr val="FF5252"/>
+                  <a:srgbClr val="0052CC"/>
                 </a:solidFill>
                 <a:latin typeface="Segoe UI Semibold"/>
               </a:rPr>
-              <a:t>The Problem</a:t>
+              <a:t>Definition</a:t>
             </a:r>
           </a:p>
           <a:p>
@@ -6484,25 +6294,16 @@
                 </a:solidFill>
                 <a:latin typeface="Segoe UI"/>
               </a:rPr>
-              <a:t>Free-text LLM responses are </a:t>
+              <a:t>LLM responses constrained to a </a:t>
             </a:r>
             <a:r>
               <a:rPr lang="en-US" sz="2000" b="1" dirty="0">
                 <a:solidFill>
-                  <a:srgbClr val="FF5252"/>
+                  <a:srgbClr val="0052CC"/>
                 </a:solidFill>
                 <a:latin typeface="Segoe UI"/>
               </a:rPr>
-              <a:t>unpredictable</a:t>
-            </a:r>
-            <a:r>
-              <a:rPr lang="en-US" sz="2000" dirty="0">
-                <a:solidFill>
-                  <a:srgbClr val="2E2E2E"/>
-                </a:solidFill>
-                <a:latin typeface="Segoe UI"/>
-              </a:rPr>
-              <a:t> and break downstream systems</a:t>
+              <a:t>predefined JSON Schema</a:t>
             </a:r>
           </a:p>
           <a:p>
@@ -6517,7 +6318,25 @@
                 </a:solidFill>
                 <a:latin typeface="Segoe UI"/>
               </a:rPr>
-              <a:t>Regex/string parsing is fragile, error-prone, and costly to maintain</a:t>
+              <a:t>Guarantees </a:t>
+            </a:r>
+            <a:r>
+              <a:rPr lang="en-US" sz="2000" b="1" dirty="0">
+                <a:solidFill>
+                  <a:srgbClr val="0052CC"/>
+                </a:solidFill>
+                <a:latin typeface="Segoe UI"/>
+              </a:rPr>
+              <a:t>type-safe, parseable output</a:t>
+            </a:r>
+            <a:r>
+              <a:rPr lang="en-US" sz="2000" dirty="0">
+                <a:solidFill>
+                  <a:srgbClr val="2E2E2E"/>
+                </a:solidFill>
+                <a:latin typeface="Segoe UI"/>
+              </a:rPr>
+              <a:t> every time</a:t>
             </a:r>
           </a:p>
           <a:p>
@@ -6532,32 +6351,7 @@
                 </a:solidFill>
                 <a:latin typeface="Segoe UI"/>
               </a:rPr>
-              <a:t>Retry loops waste tokens, increase latency, and add complexity</a:t>
-            </a:r>
-          </a:p>
-          <a:p>
-            <a:pPr marL="0" indent="0">
-              <a:buNone/>
-            </a:pPr>
-            <a:endParaRPr lang="en-US" sz="2000" dirty="0">
-              <a:solidFill>
-                <a:srgbClr val="2E2E2E"/>
-              </a:solidFill>
-              <a:latin typeface="Segoe UI"/>
-            </a:endParaRPr>
-          </a:p>
-          <a:p>
-            <a:pPr>
-              <a:buNone/>
-            </a:pPr>
-            <a:r>
-              <a:rPr lang="en-US" sz="2000" b="1" dirty="0">
-                <a:solidFill>
-                  <a:srgbClr val="00C853"/>
-                </a:solidFill>
-                <a:latin typeface="Segoe UI Semibold"/>
-              </a:rPr>
-              <a:t>The Solution</a:t>
+              <a:t>Eliminates post-processing, regex, and retry logic</a:t>
             </a:r>
           </a:p>
           <a:p>
@@ -6565,31 +6359,22 @@
               <a:buFont typeface="Arial"/>
               <a:buChar char="▸"/>
             </a:pPr>
-            <a:r>
-              <a:rPr lang="en-US" sz="2000" dirty="0">
-                <a:solidFill>
-                  <a:srgbClr val="2E2E2E"/>
-                </a:solidFill>
-                <a:latin typeface="Segoe UI"/>
-              </a:rPr>
-              <a:t>Structured Outputs = </a:t>
-            </a:r>
+            <a:endParaRPr lang="en-US" sz="2000" dirty="0">
+              <a:latin typeface="Segoe UI"/>
+            </a:endParaRPr>
+          </a:p>
+          <a:p>
+            <a:pPr marL="0" indent="0">
+              <a:buNone/>
+            </a:pPr>
             <a:r>
               <a:rPr lang="en-US" sz="2000" b="1" dirty="0">
                 <a:solidFill>
-                  <a:srgbClr val="00C853"/>
-                </a:solidFill>
-              </a:rPr>
-              <a:t>100% schema-compliant </a:t>
-            </a:r>
-            <a:r>
-              <a:rPr lang="en-US" sz="2000" dirty="0">
-                <a:solidFill>
-                  <a:srgbClr val="2E2E2E"/>
-                </a:solidFill>
-                <a:latin typeface="Segoe UI"/>
-              </a:rPr>
-              <a:t>responses</a:t>
+                  <a:srgbClr val="0052CC"/>
+                </a:solidFill>
+                <a:latin typeface="Segoe UI Semibold"/>
+              </a:rPr>
+              <a:t>In this talk we focus on OpenAI</a:t>
             </a:r>
           </a:p>
           <a:p>
@@ -6598,64 +6383,99 @@
               <a:buChar char="▸"/>
             </a:pPr>
             <a:r>
+              <a:rPr lang="en-US" sz="2000" dirty="0"/>
+              <a:t>other providers offer similar functionality (e.g. </a:t>
+            </a:r>
+            <a:r>
               <a:rPr lang="en-US" sz="2000" dirty="0">
-                <a:solidFill>
-                  <a:srgbClr val="2E2E2E"/>
-                </a:solidFill>
-                <a:latin typeface="Segoe UI"/>
-              </a:rPr>
-              <a:t>Production-ready from day one</a:t>
+                <a:hlinkClick r:id="rId3"/>
+              </a:rPr>
+              <a:t>Anthropic</a:t>
             </a:r>
             <a:r>
               <a:rPr lang="en-US" sz="2000" dirty="0"/>
-              <a:t> → </a:t>
+              <a:t>)</a:t>
+            </a:r>
+          </a:p>
+          <a:p>
+            <a:pPr>
+              <a:buFont typeface="Arial"/>
+              <a:buChar char="▸"/>
+            </a:pPr>
+            <a:endParaRPr lang="en-US" sz="2000" dirty="0"/>
+          </a:p>
+          <a:p>
+            <a:pPr marL="0" indent="0">
+              <a:buNone/>
+            </a:pPr>
+            <a:r>
+              <a:rPr lang="en-US" sz="2000" b="1" dirty="0">
+                <a:solidFill>
+                  <a:srgbClr val="0052CC"/>
+                </a:solidFill>
+                <a:latin typeface="Segoe UI Semibold"/>
+              </a:rPr>
+              <a:t>If you need </a:t>
+            </a:r>
+            <a:r>
+              <a:rPr lang="en-US" sz="2000" b="1" dirty="0" err="1">
+                <a:solidFill>
+                  <a:srgbClr val="0052CC"/>
+                </a:solidFill>
+                <a:latin typeface="Segoe UI Semibold"/>
+              </a:rPr>
+              <a:t>XPlat</a:t>
+            </a:r>
+            <a:r>
+              <a:rPr lang="en-US" sz="2000" b="1" dirty="0">
+                <a:solidFill>
+                  <a:srgbClr val="0052CC"/>
+                </a:solidFill>
+                <a:latin typeface="Segoe UI Semibold"/>
+              </a:rPr>
+              <a:t>, consider …</a:t>
+            </a:r>
+          </a:p>
+          <a:p>
+            <a:pPr>
+              <a:buFont typeface="Arial"/>
+              <a:buChar char="▸"/>
+            </a:pPr>
+            <a:r>
+              <a:rPr lang="en-US" sz="2000" dirty="0"/>
+              <a:t>… libs like </a:t>
             </a:r>
             <a:r>
               <a:rPr lang="en-US" sz="2000" dirty="0">
-                <a:solidFill>
-                  <a:srgbClr val="2E2E2E"/>
-                </a:solidFill>
-                <a:latin typeface="Segoe UI"/>
-              </a:rPr>
-              <a:t>no glue code required</a:t>
-            </a:r>
-          </a:p>
-        </p:txBody>
-      </p:sp>
-      <p:pic>
-        <p:nvPicPr>
-          <p:cNvPr id="4" name="Graphic 4" descr="Target icon for motivation"/>
-          <p:cNvPicPr>
-            <a:picLocks noChangeAspect="1"/>
-          </p:cNvPicPr>
-          <p:nvPr/>
-        </p:nvPicPr>
-        <p:blipFill>
-          <a:blip r:embed="rId3">
-            <a:extLst>
-              <a:ext uri="{96DAC541-7B7A-43D3-8B79-37D633B846F1}">
-                <asvg:svgBlip xmlns:asvg="http://schemas.microsoft.com/office/drawing/2016/SVG/main" r:embed="rId4"/>
-              </a:ext>
-            </a:extLst>
-          </a:blip>
-          <a:stretch>
-            <a:fillRect/>
-          </a:stretch>
-        </p:blipFill>
-        <p:spPr>
-          <a:xfrm>
-            <a:off x="11176000" y="444500"/>
-            <a:ext cx="609600" cy="609600"/>
-          </a:xfrm>
-          <a:prstGeom prst="rect">
-            <a:avLst/>
-          </a:prstGeom>
-        </p:spPr>
-      </p:pic>
+                <a:hlinkClick r:id="rId4"/>
+              </a:rPr>
+              <a:t>AI-SDK</a:t>
+            </a:r>
+            <a:endParaRPr lang="en-US" sz="2000" dirty="0"/>
+          </a:p>
+          <a:p>
+            <a:pPr>
+              <a:buFont typeface="Arial"/>
+              <a:buChar char="▸"/>
+            </a:pPr>
+            <a:r>
+              <a:rPr lang="en-US" sz="2000" dirty="0"/>
+              <a:t>… proxies like </a:t>
+            </a:r>
+            <a:r>
+              <a:rPr lang="en-US" sz="2000" dirty="0">
+                <a:hlinkClick r:id="rId5"/>
+              </a:rPr>
+              <a:t>LiteLLM</a:t>
+            </a:r>
+            <a:endParaRPr lang="en-US" sz="2000" dirty="0"/>
+          </a:p>
+        </p:txBody>
+      </p:sp>
     </p:spTree>
     <p:extLst>
       <p:ext uri="{BB962C8B-B14F-4D97-AF65-F5344CB8AC3E}">
-        <p14:creationId xmlns:p14="http://schemas.microsoft.com/office/powerpoint/2010/main" val="1409274585"/>
+        <p14:creationId xmlns:p14="http://schemas.microsoft.com/office/powerpoint/2010/main" val="405869426"/>
       </p:ext>
     </p:extLst>
   </p:cSld>
@@ -6687,7 +6507,7 @@
           <p:cNvPr id="2" name="Title 1">
             <a:extLst>
               <a:ext uri="{FF2B5EF4-FFF2-40B4-BE49-F238E27FC236}">
-                <a16:creationId xmlns:a16="http://schemas.microsoft.com/office/drawing/2014/main" id="{94BB1A4F-71CE-1549-3044-8E55A639494F}"/>
+                <a16:creationId xmlns:a16="http://schemas.microsoft.com/office/drawing/2014/main" id="{7A5C2B88-C751-7A6A-1C3D-B481F9C9E4F9}"/>
               </a:ext>
             </a:extLst>
           </p:cNvPr>
@@ -6706,12 +6526,12 @@
           <a:lstStyle/>
           <a:p>
             <a:r>
-              <a:rPr lang="en-US" sz="3200" b="1" dirty="0">
+              <a:rPr lang="en-US" sz="3200" b="1">
                 <a:solidFill>
                   <a:srgbClr val="0052CC"/>
                 </a:solidFill>
               </a:rPr>
-              <a:t>Overview of usages</a:t>
+              <a:t>Motivation: Why Structured Output?</a:t>
             </a:r>
           </a:p>
         </p:txBody>
@@ -6721,7 +6541,7 @@
           <p:cNvPr id="3" name="Content Placeholder 2">
             <a:extLst>
               <a:ext uri="{FF2B5EF4-FFF2-40B4-BE49-F238E27FC236}">
-                <a16:creationId xmlns:a16="http://schemas.microsoft.com/office/drawing/2014/main" id="{F3DF52A7-B505-52F2-2118-7BF92CF79726}"/>
+                <a16:creationId xmlns:a16="http://schemas.microsoft.com/office/drawing/2014/main" id="{61C51AB3-776D-839E-45DF-B3A756BBEA6D}"/>
               </a:ext>
             </a:extLst>
           </p:cNvPr>
@@ -6734,8 +6554,8 @@
         </p:nvSpPr>
         <p:spPr>
           <a:xfrm>
-            <a:off x="838200" y="1690689"/>
-            <a:ext cx="10515600" cy="4405312"/>
+            <a:off x="838200" y="1905000"/>
+            <a:ext cx="10515600" cy="4191000"/>
           </a:xfrm>
         </p:spPr>
         <p:txBody>
@@ -6743,20 +6563,87 @@
             <a:normAutofit/>
           </a:bodyPr>
           <a:lstStyle/>
+          <a:p>
+            <a:pPr>
+              <a:buNone/>
+            </a:pPr>
+            <a:r>
+              <a:rPr lang="en-US" sz="2000" b="1" dirty="0">
+                <a:solidFill>
+                  <a:srgbClr val="FF5252"/>
+                </a:solidFill>
+                <a:latin typeface="Segoe UI Semibold"/>
+              </a:rPr>
+              <a:t>The Problem</a:t>
+            </a:r>
+          </a:p>
           <a:p>
             <a:pPr>
               <a:buFont typeface="Arial"/>
               <a:buChar char="▸"/>
             </a:pPr>
             <a:r>
+              <a:rPr lang="en-US" sz="2000" dirty="0">
+                <a:solidFill>
+                  <a:srgbClr val="2E2E2E"/>
+                </a:solidFill>
+                <a:latin typeface="Segoe UI"/>
+              </a:rPr>
+              <a:t>Free-text LLM responses are </a:t>
+            </a:r>
+            <a:r>
               <a:rPr lang="en-US" sz="2000" b="1" dirty="0">
                 <a:solidFill>
-                  <a:srgbClr val="0052CC"/>
-                </a:solidFill>
-                <a:latin typeface="Segoe UI Semibold"/>
-              </a:rPr>
-              <a:t>Data extraction and parsing</a:t>
-            </a:r>
+                  <a:srgbClr val="FF5252"/>
+                </a:solidFill>
+                <a:latin typeface="Segoe UI"/>
+              </a:rPr>
+              <a:t>unpredictable</a:t>
+            </a:r>
+            <a:r>
+              <a:rPr lang="en-US" sz="2000" dirty="0">
+                <a:solidFill>
+                  <a:srgbClr val="2E2E2E"/>
+                </a:solidFill>
+                <a:latin typeface="Segoe UI"/>
+              </a:rPr>
+              <a:t> and break downstream systems</a:t>
+            </a:r>
+          </a:p>
+          <a:p>
+            <a:pPr>
+              <a:buFont typeface="Arial"/>
+              <a:buChar char="▸"/>
+            </a:pPr>
+            <a:r>
+              <a:rPr lang="en-US" sz="2000" dirty="0">
+                <a:solidFill>
+                  <a:srgbClr val="2E2E2E"/>
+                </a:solidFill>
+                <a:latin typeface="Segoe UI"/>
+              </a:rPr>
+              <a:t>Regex/string parsing is fragile, error-prone, and costly to maintain</a:t>
+            </a:r>
+          </a:p>
+          <a:p>
+            <a:pPr>
+              <a:buFont typeface="Arial"/>
+              <a:buChar char="▸"/>
+            </a:pPr>
+            <a:r>
+              <a:rPr lang="en-US" sz="2000" dirty="0">
+                <a:solidFill>
+                  <a:srgbClr val="2E2E2E"/>
+                </a:solidFill>
+                <a:latin typeface="Segoe UI"/>
+              </a:rPr>
+              <a:t>Retry loops waste tokens, increase latency, and add complexity</a:t>
+            </a:r>
+          </a:p>
+          <a:p>
+            <a:pPr marL="0" indent="0">
+              <a:buNone/>
+            </a:pPr>
             <a:endParaRPr lang="en-US" sz="2000" dirty="0">
               <a:solidFill>
                 <a:srgbClr val="2E2E2E"/>
@@ -6765,37 +6652,18 @@
             </a:endParaRPr>
           </a:p>
           <a:p>
-            <a:pPr lvl="1">
-              <a:buFont typeface="Arial"/>
-              <a:buChar char="▸"/>
+            <a:pPr>
+              <a:buNone/>
             </a:pPr>
             <a:r>
-              <a:rPr lang="en-US" sz="1800" dirty="0">
-                <a:latin typeface="Segoe UI"/>
-              </a:rPr>
-              <a:t>e</a:t>
-            </a:r>
-            <a:r>
-              <a:rPr lang="en-US" sz="1800" dirty="0">
-                <a:solidFill>
-                  <a:srgbClr val="2E2E2E"/>
-                </a:solidFill>
-                <a:latin typeface="Segoe UI"/>
-              </a:rPr>
-              <a:t>.g</a:t>
-            </a:r>
-            <a:r>
-              <a:rPr lang="en-US" sz="1800" dirty="0">
-                <a:latin typeface="Segoe UI"/>
-              </a:rPr>
-              <a:t>. from documents (like PDF, JPEG, Word, PPT) for RAG</a:t>
-            </a:r>
-            <a:endParaRPr lang="en-US" sz="1800" dirty="0">
-              <a:solidFill>
-                <a:srgbClr val="2E2E2E"/>
-              </a:solidFill>
-              <a:latin typeface="Segoe UI"/>
-            </a:endParaRPr>
+              <a:rPr lang="en-US" sz="2000" b="1" dirty="0">
+                <a:solidFill>
+                  <a:srgbClr val="00C853"/>
+                </a:solidFill>
+                <a:latin typeface="Segoe UI Semibold"/>
+              </a:rPr>
+              <a:t>The Solution</a:t>
+            </a:r>
           </a:p>
           <a:p>
             <a:pPr>
@@ -6803,38 +6671,31 @@
               <a:buChar char="▸"/>
             </a:pPr>
             <a:r>
+              <a:rPr lang="en-US" sz="2000" dirty="0">
+                <a:solidFill>
+                  <a:srgbClr val="2E2E2E"/>
+                </a:solidFill>
+                <a:latin typeface="Segoe UI"/>
+              </a:rPr>
+              <a:t>Structured Outputs = </a:t>
+            </a:r>
+            <a:r>
               <a:rPr lang="en-US" sz="2000" b="1" dirty="0">
                 <a:solidFill>
-                  <a:srgbClr val="0052CC"/>
-                </a:solidFill>
-                <a:latin typeface="Segoe UI Semibold"/>
-              </a:rPr>
-              <a:t>Create semi-structured reports</a:t>
-            </a:r>
-            <a:endParaRPr lang="en-US" sz="2000" dirty="0">
-              <a:solidFill>
-                <a:srgbClr val="2E2E2E"/>
-              </a:solidFill>
-              <a:latin typeface="Segoe UI"/>
-            </a:endParaRPr>
-          </a:p>
-          <a:p>
-            <a:pPr lvl="1">
-              <a:buFont typeface="Arial"/>
-              <a:buChar char="▸"/>
-            </a:pPr>
-            <a:r>
-              <a:rPr lang="en-US" sz="1800" dirty="0">
+                  <a:srgbClr val="00C853"/>
+                </a:solidFill>
+              </a:rPr>
+              <a:t>100% schema-compliant </a:t>
+            </a:r>
+            <a:r>
+              <a:rPr lang="en-US" sz="2000" dirty="0">
+                <a:solidFill>
+                  <a:srgbClr val="2E2E2E"/>
+                </a:solidFill>
                 <a:latin typeface="Segoe UI"/>
               </a:rPr>
-              <a:t>e.g. summaries, incident reports, etc.</a:t>
-            </a:r>
-            <a:endParaRPr lang="en-US" sz="1800" dirty="0">
-              <a:solidFill>
-                <a:srgbClr val="2E2E2E"/>
-              </a:solidFill>
-              <a:latin typeface="Segoe UI"/>
-            </a:endParaRPr>
+              <a:t>responses</a:t>
+            </a:r>
           </a:p>
           <a:p>
             <a:pPr>
@@ -6842,52 +6703,17 @@
               <a:buChar char="▸"/>
             </a:pPr>
             <a:r>
-              <a:rPr lang="en-US" sz="2000" b="1" dirty="0">
-                <a:solidFill>
-                  <a:srgbClr val="0052CC"/>
-                </a:solidFill>
-                <a:latin typeface="Segoe UI Semibold"/>
-              </a:rPr>
-              <a:t>Form filling</a:t>
-            </a:r>
-            <a:endParaRPr lang="en-US" sz="2000" dirty="0">
-              <a:solidFill>
-                <a:srgbClr val="2E2E2E"/>
-              </a:solidFill>
-              <a:latin typeface="Segoe UI"/>
-            </a:endParaRPr>
-          </a:p>
-          <a:p>
-            <a:pPr lvl="1">
-              <a:buFont typeface="Arial"/>
-              <a:buChar char="▸"/>
-            </a:pPr>
-            <a:r>
-              <a:rPr lang="en-US" sz="1800" dirty="0">
+              <a:rPr lang="en-US" sz="2000" dirty="0">
+                <a:solidFill>
+                  <a:srgbClr val="2E2E2E"/>
+                </a:solidFill>
                 <a:latin typeface="Segoe UI"/>
               </a:rPr>
-              <a:t>e.g. pre-fill form in UI from user-request</a:t>
-            </a:r>
-            <a:endParaRPr lang="en-US" sz="1800" dirty="0">
-              <a:solidFill>
-                <a:srgbClr val="2E2E2E"/>
-              </a:solidFill>
-              <a:latin typeface="Segoe UI"/>
-            </a:endParaRPr>
-          </a:p>
-          <a:p>
-            <a:pPr>
-              <a:buFont typeface="Arial"/>
-              <a:buChar char="▸"/>
-            </a:pPr>
-            <a:r>
-              <a:rPr lang="en-US" sz="2000" b="1" dirty="0">
-                <a:solidFill>
-                  <a:srgbClr val="0052CC"/>
-                </a:solidFill>
-                <a:latin typeface="Segoe UI Semibold"/>
-              </a:rPr>
-              <a:t>Content classification</a:t>
+              <a:t>Production-ready from day one</a:t>
+            </a:r>
+            <a:r>
+              <a:rPr lang="en-US" sz="2000" dirty="0"/>
+              <a:t> → </a:t>
             </a:r>
             <a:r>
               <a:rPr lang="en-US" sz="2000" dirty="0">
@@ -6896,123 +6722,15 @@
                 </a:solidFill>
                 <a:latin typeface="Segoe UI"/>
               </a:rPr>
-              <a:t> </a:t>
-            </a:r>
-          </a:p>
-          <a:p>
-            <a:pPr lvl="1">
-              <a:buFont typeface="Arial"/>
-              <a:buChar char="▸"/>
-            </a:pPr>
-            <a:r>
-              <a:rPr lang="en-US" sz="1800" dirty="0">
-                <a:latin typeface="Segoe UI"/>
-              </a:rPr>
-              <a:t>e.g. for content moderation, structured customer feedback</a:t>
-            </a:r>
-            <a:endParaRPr lang="en-US" sz="1800" dirty="0">
-              <a:solidFill>
-                <a:srgbClr val="2E2E2E"/>
-              </a:solidFill>
-              <a:latin typeface="Segoe UI"/>
-            </a:endParaRPr>
-          </a:p>
-          <a:p>
-            <a:pPr>
-              <a:buFont typeface="Arial"/>
-              <a:buChar char="▸"/>
-            </a:pPr>
-            <a:r>
-              <a:rPr lang="en-US" sz="2000" b="1" dirty="0">
-                <a:solidFill>
-                  <a:srgbClr val="0052CC"/>
-                </a:solidFill>
-                <a:latin typeface="Segoe UI Semibold"/>
-              </a:rPr>
-              <a:t>Function calling arguments</a:t>
-            </a:r>
-          </a:p>
-          <a:p>
-            <a:pPr lvl="1">
-              <a:buFont typeface="Arial"/>
-              <a:buChar char="▸"/>
-            </a:pPr>
-            <a:r>
-              <a:rPr lang="en-US" sz="1800" dirty="0">
-                <a:latin typeface="Segoe UI"/>
-              </a:rPr>
-              <a:t>LLM provides function arguments</a:t>
-            </a:r>
-          </a:p>
-          <a:p>
-            <a:pPr>
-              <a:buFont typeface="Arial"/>
-              <a:buChar char="▸"/>
-            </a:pPr>
-            <a:r>
-              <a:rPr lang="en-US" sz="2000" b="1" dirty="0">
-                <a:solidFill>
-                  <a:srgbClr val="0052CC"/>
-                </a:solidFill>
-                <a:latin typeface="Segoe UI Semibold"/>
-              </a:rPr>
-              <a:t>Train of thought</a:t>
-            </a:r>
-            <a:endParaRPr lang="en-US" sz="2000" dirty="0">
-              <a:solidFill>
-                <a:srgbClr val="2E2E2E"/>
-              </a:solidFill>
-              <a:latin typeface="Segoe UI"/>
-            </a:endParaRPr>
-          </a:p>
-          <a:p>
-            <a:pPr lvl="1">
-              <a:buFont typeface="Arial"/>
-              <a:buChar char="▸"/>
-            </a:pPr>
-            <a:r>
-              <a:rPr lang="en-US" sz="1800" dirty="0">
-                <a:latin typeface="Segoe UI"/>
-              </a:rPr>
-              <a:t>Show reasoning process step-by-step</a:t>
-            </a:r>
-          </a:p>
-        </p:txBody>
-      </p:sp>
-      <p:pic>
-        <p:nvPicPr>
-          <p:cNvPr id="4" name="Graphic 4" descr="Gears icon for capabilities"/>
-          <p:cNvPicPr>
-            <a:picLocks noChangeAspect="1"/>
-          </p:cNvPicPr>
-          <p:nvPr/>
-        </p:nvPicPr>
-        <p:blipFill>
-          <a:blip r:embed="rId3">
-            <a:extLst>
-              <a:ext uri="{96DAC541-7B7A-43D3-8B79-37D633B846F1}">
-                <asvg:svgBlip xmlns:asvg="http://schemas.microsoft.com/office/drawing/2016/SVG/main" r:embed="rId4"/>
-              </a:ext>
-            </a:extLst>
-          </a:blip>
-          <a:stretch>
-            <a:fillRect/>
-          </a:stretch>
-        </p:blipFill>
-        <p:spPr>
-          <a:xfrm>
-            <a:off x="11176000" y="444500"/>
-            <a:ext cx="609600" cy="609600"/>
-          </a:xfrm>
-          <a:prstGeom prst="rect">
-            <a:avLst/>
-          </a:prstGeom>
-        </p:spPr>
-      </p:pic>
+              <a:t>no glue code required</a:t>
+            </a:r>
+          </a:p>
+        </p:txBody>
+      </p:sp>
     </p:spTree>
     <p:extLst>
       <p:ext uri="{BB962C8B-B14F-4D97-AF65-F5344CB8AC3E}">
-        <p14:creationId xmlns:p14="http://schemas.microsoft.com/office/powerpoint/2010/main" val="1052435720"/>
+        <p14:creationId xmlns:p14="http://schemas.microsoft.com/office/powerpoint/2010/main" val="1409274585"/>
       </p:ext>
     </p:extLst>
   </p:cSld>
@@ -7044,7 +6762,7 @@
           <p:cNvPr id="2" name="Title 1">
             <a:extLst>
               <a:ext uri="{FF2B5EF4-FFF2-40B4-BE49-F238E27FC236}">
-                <a16:creationId xmlns:a16="http://schemas.microsoft.com/office/drawing/2014/main" id="{AC273CA9-7DC9-98A3-C3FE-64863B290B42}"/>
+                <a16:creationId xmlns:a16="http://schemas.microsoft.com/office/drawing/2014/main" id="{94BB1A4F-71CE-1549-3044-8E55A639494F}"/>
               </a:ext>
             </a:extLst>
           </p:cNvPr>
@@ -7063,12 +6781,12 @@
           <a:lstStyle/>
           <a:p>
             <a:r>
-              <a:rPr lang="en-US" sz="3200" b="1">
+              <a:rPr lang="en-US" sz="3200" b="1" dirty="0">
                 <a:solidFill>
                   <a:srgbClr val="0052CC"/>
                 </a:solidFill>
               </a:rPr>
-              <a:t>Context-Free Grammar (CFG)</a:t>
+              <a:t>Overview of usages</a:t>
             </a:r>
           </a:p>
         </p:txBody>
@@ -7078,7 +6796,7 @@
           <p:cNvPr id="3" name="Content Placeholder 2">
             <a:extLst>
               <a:ext uri="{FF2B5EF4-FFF2-40B4-BE49-F238E27FC236}">
-                <a16:creationId xmlns:a16="http://schemas.microsoft.com/office/drawing/2014/main" id="{F7ACBD00-EE0B-1799-965F-3D0888EB55CC}"/>
+                <a16:creationId xmlns:a16="http://schemas.microsoft.com/office/drawing/2014/main" id="{F3DF52A7-B505-52F2-2118-7BF92CF79726}"/>
               </a:ext>
             </a:extLst>
           </p:cNvPr>
@@ -7091,8 +6809,8 @@
         </p:nvSpPr>
         <p:spPr>
           <a:xfrm>
-            <a:off x="838200" y="1905000"/>
-            <a:ext cx="10515600" cy="4191000"/>
+            <a:off x="838200" y="1690689"/>
+            <a:ext cx="10515600" cy="4405312"/>
           </a:xfrm>
         </p:spPr>
         <p:txBody>
@@ -7100,103 +6818,26 @@
             <a:normAutofit/>
           </a:bodyPr>
           <a:lstStyle/>
-          <a:p>
-            <a:pPr>
-              <a:buNone/>
-            </a:pPr>
-            <a:r>
-              <a:rPr lang="en-US" sz="2000" b="1" dirty="0">
-                <a:solidFill>
-                  <a:srgbClr val="0052CC"/>
-                </a:solidFill>
-                <a:latin typeface="Segoe UI Semibold"/>
-              </a:rPr>
-              <a:t>How It Works Under the Hood</a:t>
-            </a:r>
-          </a:p>
           <a:p>
             <a:pPr>
               <a:buFont typeface="Arial"/>
               <a:buChar char="▸"/>
             </a:pPr>
             <a:r>
-              <a:rPr lang="en-US" sz="2000" dirty="0">
-                <a:solidFill>
-                  <a:srgbClr val="2E2E2E"/>
-                </a:solidFill>
-                <a:latin typeface="Segoe UI"/>
-              </a:rPr>
-              <a:t>JSON Schema is converted to a </a:t>
-            </a:r>
-            <a:r>
               <a:rPr lang="en-US" sz="2000" b="1" dirty="0">
                 <a:solidFill>
                   <a:srgbClr val="0052CC"/>
                 </a:solidFill>
-                <a:latin typeface="Segoe UI"/>
-              </a:rPr>
-              <a:t>Context-Free Grammar</a:t>
-            </a:r>
-          </a:p>
-          <a:p>
-            <a:pPr>
-              <a:buFont typeface="Arial"/>
-              <a:buChar char="▸"/>
-            </a:pPr>
-            <a:r>
-              <a:rPr lang="en-US" sz="2000" dirty="0">
-                <a:solidFill>
-                  <a:srgbClr val="2E2E2E"/>
-                </a:solidFill>
-                <a:latin typeface="Segoe UI"/>
-              </a:rPr>
-              <a:t>CFG </a:t>
-            </a:r>
-            <a:r>
-              <a:rPr lang="en-US" sz="2000" b="1" dirty="0">
-                <a:solidFill>
-                  <a:srgbClr val="FFC107"/>
-                </a:solidFill>
-                <a:latin typeface="Segoe UI"/>
-              </a:rPr>
-              <a:t>constrains token sampling</a:t>
-            </a:r>
-            <a:r>
-              <a:rPr lang="en-US" sz="2000" dirty="0">
-                <a:solidFill>
-                  <a:srgbClr val="2E2E2E"/>
-                </a:solidFill>
-                <a:latin typeface="Segoe UI"/>
-              </a:rPr>
-              <a:t> at inference time</a:t>
-            </a:r>
-          </a:p>
-          <a:p>
-            <a:pPr>
-              <a:buFont typeface="Arial"/>
-              <a:buChar char="▸"/>
-            </a:pPr>
-            <a:r>
-              <a:rPr lang="en-US" sz="2000" dirty="0">
-                <a:solidFill>
-                  <a:srgbClr val="2E2E2E"/>
-                </a:solidFill>
-                <a:latin typeface="Segoe UI"/>
-              </a:rPr>
-              <a:t>Only valid grammar transitions are allowed for next token</a:t>
-            </a:r>
-          </a:p>
-          <a:p>
-            <a:pPr>
-              <a:buFont typeface="Arial"/>
-              <a:buChar char="▸"/>
-            </a:pPr>
-            <a:r>
-              <a:rPr lang="en-US" sz="2000" dirty="0">
-                <a:latin typeface="Segoe UI"/>
-              </a:rPr>
-              <a:t>Supported Grammar Syntax</a:t>
-            </a:r>
+                <a:latin typeface="Segoe UI Semibold"/>
+              </a:rPr>
+              <a:t>Data extraction and parsing</a:t>
+            </a:r>
+            <a:endParaRPr lang="en-US" sz="2000" dirty="0">
+              <a:solidFill>
+                <a:srgbClr val="2E2E2E"/>
+              </a:solidFill>
+              <a:latin typeface="Segoe UI"/>
+            </a:endParaRPr>
           </a:p>
           <a:p>
             <a:pPr lvl="1">
@@ -7205,13 +6846,24 @@
             </a:pPr>
             <a:r>
               <a:rPr lang="en-US" sz="1800" dirty="0">
+                <a:latin typeface="Segoe UI"/>
+              </a:rPr>
+              <a:t>e</a:t>
+            </a:r>
+            <a:r>
+              <a:rPr lang="en-US" sz="1800" dirty="0">
                 <a:solidFill>
                   <a:srgbClr val="2E2E2E"/>
                 </a:solidFill>
                 <a:latin typeface="Segoe UI"/>
-                <a:hlinkClick r:id="rId3"/>
-              </a:rPr>
-              <a:t>Lark</a:t>
+              </a:rPr>
+              <a:t>.g</a:t>
+            </a:r>
+            <a:r>
+              <a:rPr lang="en-US" sz="1800" dirty="0">
+                <a:latin typeface="Segoe UI"/>
+              </a:rPr>
+              <a:t>. from documents (like PDF, JPEG, Word, PPT) for RAG</a:t>
             </a:r>
             <a:endParaRPr lang="en-US" sz="1800" dirty="0">
               <a:solidFill>
@@ -7221,6 +6873,27 @@
             </a:endParaRPr>
           </a:p>
           <a:p>
+            <a:pPr>
+              <a:buFont typeface="Arial"/>
+              <a:buChar char="▸"/>
+            </a:pPr>
+            <a:r>
+              <a:rPr lang="en-US" sz="2000" b="1" dirty="0">
+                <a:solidFill>
+                  <a:srgbClr val="0052CC"/>
+                </a:solidFill>
+                <a:latin typeface="Segoe UI Semibold"/>
+              </a:rPr>
+              <a:t>Create semi-structured reports</a:t>
+            </a:r>
+            <a:endParaRPr lang="en-US" sz="2000" dirty="0">
+              <a:solidFill>
+                <a:srgbClr val="2E2E2E"/>
+              </a:solidFill>
+              <a:latin typeface="Segoe UI"/>
+            </a:endParaRPr>
+          </a:p>
+          <a:p>
             <a:pPr lvl="1">
               <a:buFont typeface="Arial"/>
               <a:buChar char="▸"/>
@@ -7228,9 +6901,8 @@
             <a:r>
               <a:rPr lang="en-US" sz="1800" dirty="0">
                 <a:latin typeface="Segoe UI"/>
-                <a:hlinkClick r:id="rId4"/>
-              </a:rPr>
-              <a:t>Regex</a:t>
+              </a:rPr>
+              <a:t>e.g. summaries, incident reports, etc.</a:t>
             </a:r>
             <a:endParaRPr lang="en-US" sz="1800" dirty="0">
               <a:solidFill>
@@ -7239,42 +6911,153 @@
               <a:latin typeface="Segoe UI"/>
             </a:endParaRPr>
           </a:p>
-        </p:txBody>
-      </p:sp>
-      <p:pic>
-        <p:nvPicPr>
-          <p:cNvPr id="4" name="Graphic 4" descr="Gear icon for CFG"/>
-          <p:cNvPicPr>
-            <a:picLocks noChangeAspect="1"/>
-          </p:cNvPicPr>
-          <p:nvPr/>
-        </p:nvPicPr>
-        <p:blipFill>
-          <a:blip r:embed="rId5">
-            <a:extLst>
-              <a:ext uri="{96DAC541-7B7A-43D3-8B79-37D633B846F1}">
-                <asvg:svgBlip xmlns:asvg="http://schemas.microsoft.com/office/drawing/2016/SVG/main" r:embed="rId6"/>
-              </a:ext>
-            </a:extLst>
-          </a:blip>
-          <a:stretch>
-            <a:fillRect/>
-          </a:stretch>
-        </p:blipFill>
-        <p:spPr>
-          <a:xfrm>
-            <a:off x="11176000" y="444500"/>
-            <a:ext cx="609600" cy="609600"/>
-          </a:xfrm>
-          <a:prstGeom prst="rect">
-            <a:avLst/>
-          </a:prstGeom>
-        </p:spPr>
-      </p:pic>
+          <a:p>
+            <a:pPr>
+              <a:buFont typeface="Arial"/>
+              <a:buChar char="▸"/>
+            </a:pPr>
+            <a:r>
+              <a:rPr lang="en-US" sz="2000" b="1" dirty="0">
+                <a:solidFill>
+                  <a:srgbClr val="0052CC"/>
+                </a:solidFill>
+                <a:latin typeface="Segoe UI Semibold"/>
+              </a:rPr>
+              <a:t>Form filling</a:t>
+            </a:r>
+            <a:endParaRPr lang="en-US" sz="2000" dirty="0">
+              <a:solidFill>
+                <a:srgbClr val="2E2E2E"/>
+              </a:solidFill>
+              <a:latin typeface="Segoe UI"/>
+            </a:endParaRPr>
+          </a:p>
+          <a:p>
+            <a:pPr lvl="1">
+              <a:buFont typeface="Arial"/>
+              <a:buChar char="▸"/>
+            </a:pPr>
+            <a:r>
+              <a:rPr lang="en-US" sz="1800" dirty="0">
+                <a:latin typeface="Segoe UI"/>
+              </a:rPr>
+              <a:t>e.g. pre-fill form in UI from user-request</a:t>
+            </a:r>
+            <a:endParaRPr lang="en-US" sz="1800" dirty="0">
+              <a:solidFill>
+                <a:srgbClr val="2E2E2E"/>
+              </a:solidFill>
+              <a:latin typeface="Segoe UI"/>
+            </a:endParaRPr>
+          </a:p>
+          <a:p>
+            <a:pPr>
+              <a:buFont typeface="Arial"/>
+              <a:buChar char="▸"/>
+            </a:pPr>
+            <a:r>
+              <a:rPr lang="en-US" sz="2000" b="1" dirty="0">
+                <a:solidFill>
+                  <a:srgbClr val="0052CC"/>
+                </a:solidFill>
+                <a:latin typeface="Segoe UI Semibold"/>
+              </a:rPr>
+              <a:t>Content classification</a:t>
+            </a:r>
+            <a:r>
+              <a:rPr lang="en-US" sz="2000" dirty="0">
+                <a:solidFill>
+                  <a:srgbClr val="2E2E2E"/>
+                </a:solidFill>
+                <a:latin typeface="Segoe UI"/>
+              </a:rPr>
+              <a:t> </a:t>
+            </a:r>
+          </a:p>
+          <a:p>
+            <a:pPr lvl="1">
+              <a:buFont typeface="Arial"/>
+              <a:buChar char="▸"/>
+            </a:pPr>
+            <a:r>
+              <a:rPr lang="en-US" sz="1800" dirty="0">
+                <a:latin typeface="Segoe UI"/>
+              </a:rPr>
+              <a:t>e.g. for content moderation, structured customer feedback</a:t>
+            </a:r>
+            <a:endParaRPr lang="en-US" sz="1800" dirty="0">
+              <a:solidFill>
+                <a:srgbClr val="2E2E2E"/>
+              </a:solidFill>
+              <a:latin typeface="Segoe UI"/>
+            </a:endParaRPr>
+          </a:p>
+          <a:p>
+            <a:pPr>
+              <a:buFont typeface="Arial"/>
+              <a:buChar char="▸"/>
+            </a:pPr>
+            <a:r>
+              <a:rPr lang="en-US" sz="2000" b="1" dirty="0">
+                <a:solidFill>
+                  <a:srgbClr val="0052CC"/>
+                </a:solidFill>
+                <a:latin typeface="Segoe UI Semibold"/>
+              </a:rPr>
+              <a:t>Function calling arguments</a:t>
+            </a:r>
+          </a:p>
+          <a:p>
+            <a:pPr lvl="1">
+              <a:buFont typeface="Arial"/>
+              <a:buChar char="▸"/>
+            </a:pPr>
+            <a:r>
+              <a:rPr lang="en-US" sz="1800" dirty="0">
+                <a:latin typeface="Segoe UI"/>
+              </a:rPr>
+              <a:t>LLM provides function arguments</a:t>
+            </a:r>
+          </a:p>
+          <a:p>
+            <a:pPr>
+              <a:buFont typeface="Arial"/>
+              <a:buChar char="▸"/>
+            </a:pPr>
+            <a:r>
+              <a:rPr lang="en-US" sz="2000" b="1" dirty="0">
+                <a:solidFill>
+                  <a:srgbClr val="0052CC"/>
+                </a:solidFill>
+                <a:latin typeface="Segoe UI Semibold"/>
+              </a:rPr>
+              <a:t>Train of thought</a:t>
+            </a:r>
+            <a:endParaRPr lang="en-US" sz="2000" dirty="0">
+              <a:solidFill>
+                <a:srgbClr val="2E2E2E"/>
+              </a:solidFill>
+              <a:latin typeface="Segoe UI"/>
+            </a:endParaRPr>
+          </a:p>
+          <a:p>
+            <a:pPr lvl="1">
+              <a:buFont typeface="Arial"/>
+              <a:buChar char="▸"/>
+            </a:pPr>
+            <a:r>
+              <a:rPr lang="en-US" sz="1800" dirty="0">
+                <a:latin typeface="Segoe UI"/>
+              </a:rPr>
+              <a:t>Show reasoning process step-by-step</a:t>
+            </a:r>
+          </a:p>
+        </p:txBody>
+      </p:sp>
     </p:spTree>
     <p:extLst>
       <p:ext uri="{BB962C8B-B14F-4D97-AF65-F5344CB8AC3E}">
-        <p14:creationId xmlns:p14="http://schemas.microsoft.com/office/powerpoint/2010/main" val="391142335"/>
+        <p14:creationId xmlns:p14="http://schemas.microsoft.com/office/powerpoint/2010/main" val="1052435720"/>
       </p:ext>
     </p:extLst>
   </p:cSld>
@@ -7496,7 +7279,7 @@
                 </a:solidFill>
                 <a:latin typeface="Segoe UI"/>
               </a:rPr>
-              <a:t>Zod model defines the extraction schema</a:t>
+              <a:t>JS/TS: Zod model defines the extraction schema</a:t>
             </a:r>
           </a:p>
           <a:p>
@@ -7540,16 +7323,6 @@
 <file path=ppt/slides/slide8.xml><?xml version="1.0" encoding="utf-8"?>
 <p:sld xmlns:a="http://schemas.openxmlformats.org/drawingml/2006/main" xmlns:r="http://schemas.openxmlformats.org/officeDocument/2006/relationships" xmlns:p="http://schemas.openxmlformats.org/presentationml/2006/main">
   <p:cSld>
-    <p:bg>
-      <p:bgPr>
-        <a:solidFill>
-          <a:srgbClr val="001A4D">
-            <a:alpha val="100000"/>
-          </a:srgbClr>
-        </a:solidFill>
-        <a:effectLst/>
-      </p:bgPr>
-    </p:bg>
     <p:spTree>
       <p:nvGrpSpPr>
         <p:cNvPr id="1" name=""/>
@@ -7569,7 +7342,7 @@
           <p:cNvPr id="2" name="Title 1">
             <a:extLst>
               <a:ext uri="{FF2B5EF4-FFF2-40B4-BE49-F238E27FC236}">
-                <a16:creationId xmlns:a16="http://schemas.microsoft.com/office/drawing/2014/main" id="{A805F6BA-EDA0-F569-CCEB-AE5E31C37AB5}"/>
+                <a16:creationId xmlns:a16="http://schemas.microsoft.com/office/drawing/2014/main" id="{AC273CA9-7DC9-98A3-C3FE-64863B290B42}"/>
               </a:ext>
             </a:extLst>
           </p:cNvPr>
@@ -7580,12 +7353,7 @@
             <p:ph type="title"/>
           </p:nvPr>
         </p:nvSpPr>
-        <p:spPr>
-          <a:xfrm>
-            <a:off x="831850" y="1016000"/>
-            <a:ext cx="10515600" cy="1524000"/>
-          </a:xfrm>
-        </p:spPr>
+        <p:spPr/>
         <p:txBody>
           <a:bodyPr>
             <a:normAutofit/>
@@ -7593,126 +7361,42 @@
           <a:lstStyle/>
           <a:p>
             <a:r>
-              <a:rPr lang="en-US" sz="2800" b="1">
-                <a:solidFill>
-                  <a:srgbClr val="FFFFFF"/>
-                </a:solidFill>
-              </a:rPr>
-              <a:t>Demo: Function Calling &amp; Structured Outputs</a:t>
-            </a:r>
-          </a:p>
-        </p:txBody>
-      </p:sp>
-      <p:sp>
-        <p:nvSpPr>
-          <p:cNvPr id="3" name="Text Placeholder 2">
-            <a:extLst>
-              <a:ext uri="{FF2B5EF4-FFF2-40B4-BE49-F238E27FC236}">
-                <a16:creationId xmlns:a16="http://schemas.microsoft.com/office/drawing/2014/main" id="{42F815BD-8FAA-1824-4EF2-A1FA2281DC34}"/>
-              </a:ext>
-            </a:extLst>
-          </p:cNvPr>
-          <p:cNvSpPr>
-            <a:spLocks noGrp="1"/>
-          </p:cNvSpPr>
-          <p:nvPr>
-            <p:ph type="body" idx="1"/>
+              <a:rPr lang="en-US" sz="3200" b="1">
+                <a:solidFill>
+                  <a:srgbClr val="0052CC"/>
+                </a:solidFill>
+              </a:rPr>
+              <a:t>Context-Free Grammar (CFG)</a:t>
+            </a:r>
+          </a:p>
+        </p:txBody>
+      </p:sp>
+      <p:sp>
+        <p:nvSpPr>
+          <p:cNvPr id="3" name="Content Placeholder 2">
+            <a:extLst>
+              <a:ext uri="{FF2B5EF4-FFF2-40B4-BE49-F238E27FC236}">
+                <a16:creationId xmlns:a16="http://schemas.microsoft.com/office/drawing/2014/main" id="{F7ACBD00-EE0B-1799-965F-3D0888EB55CC}"/>
+              </a:ext>
+            </a:extLst>
+          </p:cNvPr>
+          <p:cNvSpPr>
+            <a:spLocks noGrp="1"/>
+          </p:cNvSpPr>
+          <p:nvPr>
+            <p:ph idx="1"/>
           </p:nvPr>
         </p:nvSpPr>
         <p:spPr>
           <a:xfrm>
-            <a:off x="831850" y="2540000"/>
-            <a:ext cx="10515600" cy="762000"/>
+            <a:off x="838200" y="1905000"/>
+            <a:ext cx="10515600" cy="4191000"/>
           </a:xfrm>
         </p:spPr>
         <p:txBody>
           <a:bodyPr>
             <a:normAutofit/>
           </a:bodyPr>
-          <a:lstStyle/>
-          <a:p>
-            <a:r>
-              <a:rPr lang="en-US" sz="1800">
-                <a:solidFill>
-                  <a:srgbClr val="00A3FF"/>
-                </a:solidFill>
-              </a:rPr>
-              <a:t>Type-safe tool arguments with automatic schema validation in code</a:t>
-            </a:r>
-          </a:p>
-        </p:txBody>
-      </p:sp>
-      <p:sp>
-        <p:nvSpPr>
-          <p:cNvPr id="60" name="DemoBadge"/>
-          <p:cNvSpPr/>
-          <p:nvPr/>
-        </p:nvSpPr>
-        <p:spPr>
-          <a:xfrm>
-            <a:off x="457200" y="254000"/>
-            <a:ext cx="2286000" cy="457200"/>
-          </a:xfrm>
-          <a:prstGeom prst="roundRect">
-            <a:avLst>
-              <a:gd name="adj" fmla="val 16667"/>
-            </a:avLst>
-          </a:prstGeom>
-          <a:solidFill>
-            <a:srgbClr val="FFC107"/>
-          </a:solidFill>
-          <a:ln>
-            <a:noFill/>
-          </a:ln>
-        </p:spPr>
-        <p:txBody>
-          <a:bodyPr anchor="ctr" anchorCtr="1"/>
-          <a:lstStyle/>
-          <a:p>
-            <a:pPr algn="ctr"/>
-            <a:r>
-              <a:rPr lang="en-US" sz="1800" b="1" dirty="0">
-                <a:solidFill>
-                  <a:srgbClr val="001A4D"/>
-                </a:solidFill>
-                <a:latin typeface="Segoe UI Semibold"/>
-              </a:rPr>
-              <a:t>▶  LIVE DEMO</a:t>
-            </a:r>
-          </a:p>
-        </p:txBody>
-      </p:sp>
-      <p:sp>
-        <p:nvSpPr>
-          <p:cNvPr id="61" name="KeyPoints"/>
-          <p:cNvSpPr/>
-          <p:nvPr/>
-        </p:nvSpPr>
-        <p:spPr>
-          <a:xfrm>
-            <a:off x="457200" y="3556000"/>
-            <a:ext cx="11277600" cy="1270000"/>
-          </a:xfrm>
-          <a:prstGeom prst="roundRect">
-            <a:avLst>
-              <a:gd name="adj" fmla="val 8333"/>
-            </a:avLst>
-          </a:prstGeom>
-          <a:solidFill>
-            <a:srgbClr val="FFFFFF">
-              <a:alpha val="10000"/>
-            </a:srgbClr>
-          </a:solidFill>
-          <a:ln w="12700">
-            <a:solidFill>
-              <a:srgbClr val="00A3FF">
-                <a:alpha val="40000"/>
-              </a:srgbClr>
-            </a:solidFill>
-          </a:ln>
-        </p:spPr>
-        <p:txBody>
-          <a:bodyPr lIns="182880" tIns="91440" rIns="182880" bIns="91440" anchor="t"/>
           <a:lstStyle/>
           <a:p>
             <a:pPr>
@@ -7722,11 +7406,20 @@
             <a:r>
               <a:rPr lang="en-US" sz="2000" dirty="0">
                 <a:solidFill>
-                  <a:srgbClr val="FFFFFF"/>
+                  <a:srgbClr val="2E2E2E"/>
                 </a:solidFill>
                 <a:latin typeface="Segoe UI"/>
               </a:rPr>
-              <a:t>Define function arguments with JSON Schema parameters</a:t>
+              <a:t>JSON Schema is converted to a </a:t>
+            </a:r>
+            <a:r>
+              <a:rPr lang="en-US" sz="2000" b="1" dirty="0">
+                <a:solidFill>
+                  <a:srgbClr val="0052CC"/>
+                </a:solidFill>
+                <a:latin typeface="Segoe UI"/>
+              </a:rPr>
+              <a:t>Context-Free Grammar</a:t>
             </a:r>
           </a:p>
           <a:p>
@@ -7734,12 +7427,33 @@
               <a:buFont typeface="Arial"/>
               <a:buChar char="▸"/>
             </a:pPr>
-            <a:endParaRPr lang="en-US" sz="2000" dirty="0">
-              <a:solidFill>
-                <a:srgbClr val="FFC107"/>
-              </a:solidFill>
-              <a:latin typeface="Consolas"/>
-            </a:endParaRPr>
+            <a:r>
+              <a:rPr lang="en-US" sz="2000" dirty="0">
+                <a:solidFill>
+                  <a:srgbClr val="2E2E2E"/>
+                </a:solidFill>
+                <a:latin typeface="Segoe UI"/>
+              </a:rPr>
+              <a:t>CFG </a:t>
+            </a:r>
+            <a:r>
+              <a:rPr lang="en-US" sz="2000" b="1" dirty="0">
+                <a:solidFill>
+                  <a:srgbClr val="FFC107"/>
+                </a:solidFill>
+                <a:latin typeface="Segoe UI"/>
+              </a:rPr>
+              <a:t>constrains token sampling</a:t>
+            </a:r>
+            <a:r>
+              <a:rPr lang="en-US" sz="2000" dirty="0">
+                <a:solidFill>
+                  <a:srgbClr val="2E2E2E"/>
+                </a:solidFill>
+                <a:latin typeface="Segoe UI"/>
+              </a:rPr>
+              <a:t> at inference time</a:t>
+            </a:r>
           </a:p>
           <a:p>
             <a:pPr>
@@ -7749,19 +7463,72 @@
             <a:r>
               <a:rPr lang="en-US" sz="2000" dirty="0">
                 <a:solidFill>
-                  <a:srgbClr val="FFFFFF"/>
+                  <a:srgbClr val="2E2E2E"/>
                 </a:solidFill>
                 <a:latin typeface="Segoe UI"/>
               </a:rPr>
-              <a:t>Model generates validated function arguments - no parsing needed</a:t>
-            </a:r>
+              <a:t>Only valid grammar transitions are allowed for next token</a:t>
+            </a:r>
+          </a:p>
+          <a:p>
+            <a:pPr>
+              <a:buFont typeface="Arial"/>
+              <a:buChar char="▸"/>
+            </a:pPr>
+            <a:r>
+              <a:rPr lang="en-US" sz="2000" dirty="0">
+                <a:latin typeface="Segoe UI"/>
+              </a:rPr>
+              <a:t>Supported Grammar Syntax for DSL</a:t>
+            </a:r>
+          </a:p>
+          <a:p>
+            <a:pPr lvl="1">
+              <a:buFont typeface="Arial"/>
+              <a:buChar char="▸"/>
+            </a:pPr>
+            <a:r>
+              <a:rPr lang="en-US" sz="1800" dirty="0">
+                <a:solidFill>
+                  <a:srgbClr val="2E2E2E"/>
+                </a:solidFill>
+                <a:latin typeface="Segoe UI"/>
+                <a:hlinkClick r:id="rId3"/>
+              </a:rPr>
+              <a:t>Lark</a:t>
+            </a:r>
+            <a:endParaRPr lang="en-US" sz="1800" dirty="0">
+              <a:solidFill>
+                <a:srgbClr val="2E2E2E"/>
+              </a:solidFill>
+              <a:latin typeface="Segoe UI"/>
+            </a:endParaRPr>
+          </a:p>
+          <a:p>
+            <a:pPr lvl="1">
+              <a:buFont typeface="Arial"/>
+              <a:buChar char="▸"/>
+            </a:pPr>
+            <a:r>
+              <a:rPr lang="en-US" sz="1800" dirty="0">
+                <a:latin typeface="Segoe UI"/>
+                <a:hlinkClick r:id="rId4"/>
+              </a:rPr>
+              <a:t>Regex</a:t>
+            </a:r>
+            <a:endParaRPr lang="en-US" sz="1800" dirty="0">
+              <a:solidFill>
+                <a:srgbClr val="2E2E2E"/>
+              </a:solidFill>
+              <a:latin typeface="Segoe UI"/>
+            </a:endParaRPr>
           </a:p>
         </p:txBody>
       </p:sp>
     </p:spTree>
     <p:extLst>
       <p:ext uri="{BB962C8B-B14F-4D97-AF65-F5344CB8AC3E}">
-        <p14:creationId xmlns:p14="http://schemas.microsoft.com/office/powerpoint/2010/main" val="2577444670"/>
+        <p14:creationId xmlns:p14="http://schemas.microsoft.com/office/powerpoint/2010/main" val="391142335"/>
       </p:ext>
     </p:extLst>
   </p:cSld>

</xml_diff>